<commit_message>
auto: update 2026-04-27 16:35:24
</commit_message>
<xml_diff>
--- a/08【MEO対策エンド資料デザイン化】/MEO対策エンド資料_v5.pptx
+++ b/08【MEO対策エンド資料デザイン化】/MEO対策エンド資料_v5.pptx
@@ -3148,7 +3148,7 @@
             <a:r>
               <a:rPr sz="16000" b="1">
                 <a:solidFill>
-                  <a:srgbClr val="C2EAE8"/>
+                  <a:srgbClr val="D8F0EF"/>
                 </a:solidFill>
               </a:rPr>
               <a:t>MEO</a:t>
@@ -3528,7 +3528,7 @@
       </p:sp>
       <p:sp>
         <p:nvSpPr>
-          <p:cNvPr id="10" name="Rounded Rectangle 9"/>
+          <p:cNvPr id="10" name="Rectangle 9"/>
           <p:cNvSpPr/>
           <p:nvPr/>
         </p:nvSpPr>
@@ -3548,7 +3548,7 @@
             <a:off x="6703923" y="5040630"/>
             <a:ext cx="4875580" cy="420624"/>
           </a:xfrm>
-          <a:prstGeom prst="roundRect">
+          <a:prstGeom prst="rect">
             <a:avLst/>
           </a:prstGeom>
           <a:ln>
@@ -3647,7 +3647,7 @@
       </p:sp>
       <p:sp>
         <p:nvSpPr>
-          <p:cNvPr id="13" name="Rounded Rectangle 12"/>
+          <p:cNvPr id="13" name="Rectangle 12"/>
           <p:cNvSpPr/>
           <p:nvPr/>
         </p:nvSpPr>
@@ -3667,7 +3667,7 @@
             <a:off x="6703923" y="5543550"/>
             <a:ext cx="4875580" cy="420624"/>
           </a:xfrm>
-          <a:prstGeom prst="roundRect">
+          <a:prstGeom prst="rect">
             <a:avLst/>
           </a:prstGeom>
           <a:ln>
@@ -3766,7 +3766,7 @@
       </p:sp>
       <p:sp>
         <p:nvSpPr>
-          <p:cNvPr id="16" name="Rounded Rectangle 15"/>
+          <p:cNvPr id="16" name="Rectangle 15"/>
           <p:cNvSpPr/>
           <p:nvPr/>
         </p:nvSpPr>
@@ -3786,7 +3786,7 @@
             <a:off x="6703923" y="6046470"/>
             <a:ext cx="4875580" cy="420624"/>
           </a:xfrm>
-          <a:prstGeom prst="roundRect">
+          <a:prstGeom prst="rect">
             <a:avLst/>
           </a:prstGeom>
           <a:ln>
@@ -3935,7 +3935,7 @@
             <a:r>
               <a:rPr sz="13000" b="1">
                 <a:solidFill>
-                  <a:srgbClr val="C2EAE8"/>
+                  <a:srgbClr val="D8F0EF"/>
                 </a:solidFill>
               </a:rPr>
               <a:t>GPS</a:t>
@@ -4147,7 +4147,7 @@
           <a:p>
             <a:pPr algn="l"/>
             <a:r>
-              <a:rPr sz="3600" b="1">
+              <a:rPr sz="2600" b="1">
                 <a:solidFill>
                   <a:srgbClr val="FFFFFF"/>
                 </a:solidFill>
@@ -4210,7 +4210,7 @@
       </p:sp>
       <p:sp>
         <p:nvSpPr>
-          <p:cNvPr id="9" name="Rounded Rectangle 8"/>
+          <p:cNvPr id="9" name="Rectangle 8"/>
           <p:cNvSpPr/>
           <p:nvPr/>
         </p:nvSpPr>
@@ -4230,7 +4230,7 @@
             <a:off x="539496" y="1458468"/>
             <a:ext cx="4266133" cy="5134356"/>
           </a:xfrm>
-          <a:prstGeom prst="roundRect">
+          <a:prstGeom prst="rect">
             <a:avLst/>
           </a:prstGeom>
           <a:ln>
@@ -4789,7 +4789,7 @@
             <a:r>
               <a:rPr sz="13000" b="1">
                 <a:solidFill>
-                  <a:srgbClr val="C2EAE8"/>
+                  <a:srgbClr val="D8F0EF"/>
                 </a:solidFill>
               </a:rPr>
               <a:t>★</a:t>
@@ -5001,7 +5001,7 @@
           <a:p>
             <a:pPr algn="l"/>
             <a:r>
-              <a:rPr sz="3600" b="1">
+              <a:rPr sz="2600" b="1">
                 <a:solidFill>
                   <a:srgbClr val="FFFFFF"/>
                 </a:solidFill>
@@ -5064,7 +5064,7 @@
       </p:sp>
       <p:sp>
         <p:nvSpPr>
-          <p:cNvPr id="9" name="Rounded Rectangle 8"/>
+          <p:cNvPr id="9" name="Rectangle 8"/>
           <p:cNvSpPr/>
           <p:nvPr/>
         </p:nvSpPr>
@@ -5084,7 +5084,7 @@
             <a:off x="676656" y="1495044"/>
             <a:ext cx="2587752" cy="4722876"/>
           </a:xfrm>
-          <a:prstGeom prst="roundRect">
+          <a:prstGeom prst="rect">
             <a:avLst/>
           </a:prstGeom>
           <a:ln>
@@ -5205,7 +5205,7 @@
       </p:sp>
       <p:sp>
         <p:nvSpPr>
-          <p:cNvPr id="12" name="Rounded Rectangle 11"/>
+          <p:cNvPr id="12" name="Rectangle 11"/>
           <p:cNvSpPr/>
           <p:nvPr/>
         </p:nvSpPr>
@@ -5225,7 +5225,7 @@
             <a:off x="3401568" y="1495044"/>
             <a:ext cx="2587752" cy="4722876"/>
           </a:xfrm>
-          <a:prstGeom prst="roundRect">
+          <a:prstGeom prst="rect">
             <a:avLst/>
           </a:prstGeom>
           <a:ln>
@@ -5346,7 +5346,7 @@
       </p:sp>
       <p:sp>
         <p:nvSpPr>
-          <p:cNvPr id="15" name="Rounded Rectangle 14"/>
+          <p:cNvPr id="15" name="Rectangle 14"/>
           <p:cNvSpPr/>
           <p:nvPr/>
         </p:nvSpPr>
@@ -5366,7 +5366,7 @@
             <a:off x="6126480" y="1495044"/>
             <a:ext cx="2587752" cy="4722876"/>
           </a:xfrm>
-          <a:prstGeom prst="roundRect">
+          <a:prstGeom prst="rect">
             <a:avLst/>
           </a:prstGeom>
           <a:ln>
@@ -5487,7 +5487,7 @@
       </p:sp>
       <p:sp>
         <p:nvSpPr>
-          <p:cNvPr id="18" name="Rounded Rectangle 17"/>
+          <p:cNvPr id="18" name="Rectangle 17"/>
           <p:cNvSpPr/>
           <p:nvPr/>
         </p:nvSpPr>
@@ -5507,7 +5507,7 @@
             <a:off x="8851392" y="1495044"/>
             <a:ext cx="2587752" cy="4722876"/>
           </a:xfrm>
-          <a:prstGeom prst="roundRect">
+          <a:prstGeom prst="rect">
             <a:avLst/>
           </a:prstGeom>
           <a:ln>
@@ -5678,7 +5678,7 @@
             <a:r>
               <a:rPr sz="13000" b="1">
                 <a:solidFill>
-                  <a:srgbClr val="C2EAE8"/>
+                  <a:srgbClr val="D8F0EF"/>
                 </a:solidFill>
               </a:rPr>
               <a:t>No.1</a:t>
@@ -5890,7 +5890,7 @@
           <a:p>
             <a:pPr algn="l"/>
             <a:r>
-              <a:rPr sz="3600" b="1">
+              <a:rPr sz="2600" b="1">
                 <a:solidFill>
                   <a:srgbClr val="FFFFFF"/>
                 </a:solidFill>
@@ -5953,7 +5953,7 @@
       </p:sp>
       <p:sp>
         <p:nvSpPr>
-          <p:cNvPr id="9" name="Rounded Rectangle 8"/>
+          <p:cNvPr id="9" name="Rectangle 8"/>
           <p:cNvSpPr/>
           <p:nvPr/>
         </p:nvSpPr>
@@ -5973,7 +5973,7 @@
             <a:off x="676656" y="1476756"/>
             <a:ext cx="3496056" cy="2338578"/>
           </a:xfrm>
-          <a:prstGeom prst="roundRect">
+          <a:prstGeom prst="rect">
             <a:avLst/>
           </a:prstGeom>
           <a:ln>
@@ -6072,7 +6072,7 @@
       </p:sp>
       <p:sp>
         <p:nvSpPr>
-          <p:cNvPr id="12" name="Rounded Rectangle 11"/>
+          <p:cNvPr id="12" name="Rectangle 11"/>
           <p:cNvSpPr/>
           <p:nvPr/>
         </p:nvSpPr>
@@ -6092,7 +6092,7 @@
             <a:off x="4309872" y="1476756"/>
             <a:ext cx="3496056" cy="2338578"/>
           </a:xfrm>
-          <a:prstGeom prst="roundRect">
+          <a:prstGeom prst="rect">
             <a:avLst/>
           </a:prstGeom>
           <a:ln>
@@ -6191,7 +6191,7 @@
       </p:sp>
       <p:sp>
         <p:nvSpPr>
-          <p:cNvPr id="15" name="Rounded Rectangle 14"/>
+          <p:cNvPr id="15" name="Rectangle 14"/>
           <p:cNvSpPr/>
           <p:nvPr/>
         </p:nvSpPr>
@@ -6211,7 +6211,7 @@
             <a:off x="7943088" y="1476756"/>
             <a:ext cx="3496056" cy="2338578"/>
           </a:xfrm>
-          <a:prstGeom prst="roundRect">
+          <a:prstGeom prst="rect">
             <a:avLst/>
           </a:prstGeom>
           <a:ln>
@@ -6310,7 +6310,7 @@
       </p:sp>
       <p:sp>
         <p:nvSpPr>
-          <p:cNvPr id="18" name="Rounded Rectangle 17"/>
+          <p:cNvPr id="18" name="Rectangle 17"/>
           <p:cNvSpPr/>
           <p:nvPr/>
         </p:nvSpPr>
@@ -6330,7 +6330,7 @@
             <a:off x="676656" y="3952494"/>
             <a:ext cx="3496056" cy="2338578"/>
           </a:xfrm>
-          <a:prstGeom prst="roundRect">
+          <a:prstGeom prst="rect">
             <a:avLst/>
           </a:prstGeom>
           <a:ln>
@@ -6429,7 +6429,7 @@
       </p:sp>
       <p:sp>
         <p:nvSpPr>
-          <p:cNvPr id="21" name="Rounded Rectangle 20"/>
+          <p:cNvPr id="21" name="Rectangle 20"/>
           <p:cNvSpPr/>
           <p:nvPr/>
         </p:nvSpPr>
@@ -6449,7 +6449,7 @@
             <a:off x="4309872" y="3952494"/>
             <a:ext cx="3496056" cy="2338578"/>
           </a:xfrm>
-          <a:prstGeom prst="roundRect">
+          <a:prstGeom prst="rect">
             <a:avLst/>
           </a:prstGeom>
           <a:ln>
@@ -6548,7 +6548,7 @@
       </p:sp>
       <p:sp>
         <p:nvSpPr>
-          <p:cNvPr id="24" name="Rounded Rectangle 23"/>
+          <p:cNvPr id="24" name="Rectangle 23"/>
           <p:cNvSpPr/>
           <p:nvPr/>
         </p:nvSpPr>
@@ -6568,7 +6568,7 @@
             <a:off x="7943088" y="3952494"/>
             <a:ext cx="3496056" cy="2338578"/>
           </a:xfrm>
-          <a:prstGeom prst="roundRect">
+          <a:prstGeom prst="rect">
             <a:avLst/>
           </a:prstGeom>
           <a:ln>
@@ -7357,7 +7357,7 @@
       <p:grpSpPr/>
       <p:sp>
         <p:nvSpPr>
-          <p:cNvPr id="2" name="Rounded Rectangle 1"/>
+          <p:cNvPr id="2" name="Rectangle 1"/>
           <p:cNvSpPr/>
           <p:nvPr/>
         </p:nvSpPr>
@@ -7377,7 +7377,7 @@
             <a:off x="0" y="0"/>
             <a:ext cx="4631801" cy="6858000"/>
           </a:xfrm>
-          <a:prstGeom prst="roundRect">
+          <a:prstGeom prst="rect">
             <a:avLst/>
           </a:prstGeom>
           <a:ln>
@@ -7737,7 +7737,7 @@
       </p:sp>
       <p:sp>
         <p:nvSpPr>
-          <p:cNvPr id="11" name="Rounded Rectangle 10"/>
+          <p:cNvPr id="11" name="Rectangle 10"/>
           <p:cNvSpPr/>
           <p:nvPr/>
         </p:nvSpPr>
@@ -7757,7 +7757,7 @@
             <a:off x="4875580" y="182880"/>
             <a:ext cx="6837883" cy="2042160"/>
           </a:xfrm>
-          <a:prstGeom prst="roundRect">
+          <a:prstGeom prst="rect">
             <a:avLst/>
           </a:prstGeom>
           <a:ln>
@@ -7867,7 +7867,7 @@
       </p:sp>
       <p:sp>
         <p:nvSpPr>
-          <p:cNvPr id="14" name="Rounded Rectangle 13"/>
+          <p:cNvPr id="14" name="Rectangle 13"/>
           <p:cNvSpPr/>
           <p:nvPr/>
         </p:nvSpPr>
@@ -7887,7 +7887,7 @@
             <a:off x="4875580" y="2371344"/>
             <a:ext cx="6837883" cy="2042160"/>
           </a:xfrm>
-          <a:prstGeom prst="roundRect">
+          <a:prstGeom prst="rect">
             <a:avLst/>
           </a:prstGeom>
           <a:ln>
@@ -7997,7 +7997,7 @@
       </p:sp>
       <p:sp>
         <p:nvSpPr>
-          <p:cNvPr id="17" name="Rounded Rectangle 16"/>
+          <p:cNvPr id="17" name="Rectangle 16"/>
           <p:cNvSpPr/>
           <p:nvPr/>
         </p:nvSpPr>
@@ -8017,7 +8017,7 @@
             <a:off x="4875580" y="4559808"/>
             <a:ext cx="6837883" cy="2042160"/>
           </a:xfrm>
-          <a:prstGeom prst="roundRect">
+          <a:prstGeom prst="rect">
             <a:avLst/>
           </a:prstGeom>
           <a:ln>
@@ -8177,7 +8177,7 @@
             <a:r>
               <a:rPr sz="13000" b="1">
                 <a:solidFill>
-                  <a:srgbClr val="C2EAE8"/>
+                  <a:srgbClr val="D8F0EF"/>
                 </a:solidFill>
               </a:rPr>
               <a:t>POST</a:t>
@@ -8389,7 +8389,7 @@
           <a:p>
             <a:pPr algn="l"/>
             <a:r>
-              <a:rPr sz="3600" b="1">
+              <a:rPr sz="2600" b="1">
                 <a:solidFill>
                   <a:srgbClr val="FFFFFF"/>
                 </a:solidFill>
@@ -8452,7 +8452,7 @@
       </p:sp>
       <p:sp>
         <p:nvSpPr>
-          <p:cNvPr id="9" name="Rounded Rectangle 8"/>
+          <p:cNvPr id="9" name="Rectangle 8"/>
           <p:cNvSpPr/>
           <p:nvPr/>
         </p:nvSpPr>
@@ -8472,7 +8472,7 @@
             <a:off x="539496" y="1458468"/>
             <a:ext cx="11173968" cy="640080"/>
           </a:xfrm>
-          <a:prstGeom prst="roundRect">
+          <a:prstGeom prst="rect">
             <a:avLst/>
           </a:prstGeom>
           <a:ln>
@@ -8537,7 +8537,7 @@
       </p:sp>
       <p:sp>
         <p:nvSpPr>
-          <p:cNvPr id="11" name="Rounded Rectangle 10"/>
+          <p:cNvPr id="11" name="Rectangle 10"/>
           <p:cNvSpPr/>
           <p:nvPr/>
         </p:nvSpPr>
@@ -8557,7 +8557,7 @@
             <a:off x="676656" y="2253996"/>
             <a:ext cx="3496056" cy="4128516"/>
           </a:xfrm>
-          <a:prstGeom prst="roundRect">
+          <a:prstGeom prst="rect">
             <a:avLst/>
           </a:prstGeom>
           <a:ln>
@@ -8678,7 +8678,7 @@
       </p:sp>
       <p:sp>
         <p:nvSpPr>
-          <p:cNvPr id="14" name="Rounded Rectangle 13"/>
+          <p:cNvPr id="14" name="Rectangle 13"/>
           <p:cNvSpPr/>
           <p:nvPr/>
         </p:nvSpPr>
@@ -8698,7 +8698,7 @@
             <a:off x="4309872" y="2253996"/>
             <a:ext cx="3496056" cy="4128516"/>
           </a:xfrm>
-          <a:prstGeom prst="roundRect">
+          <a:prstGeom prst="rect">
             <a:avLst/>
           </a:prstGeom>
           <a:ln>
@@ -8819,7 +8819,7 @@
       </p:sp>
       <p:sp>
         <p:nvSpPr>
-          <p:cNvPr id="17" name="Rounded Rectangle 16"/>
+          <p:cNvPr id="17" name="Rectangle 16"/>
           <p:cNvSpPr/>
           <p:nvPr/>
         </p:nvSpPr>
@@ -8839,7 +8839,7 @@
             <a:off x="7943088" y="2253996"/>
             <a:ext cx="3496056" cy="4128516"/>
           </a:xfrm>
-          <a:prstGeom prst="roundRect">
+          <a:prstGeom prst="rect">
             <a:avLst/>
           </a:prstGeom>
           <a:ln>
@@ -9044,7 +9044,7 @@
             <a:r>
               <a:rPr sz="13000" b="1">
                 <a:solidFill>
-                  <a:srgbClr val="C2EAE8"/>
+                  <a:srgbClr val="D8F0EF"/>
                 </a:solidFill>
               </a:rPr>
               <a:t>∞</a:t>
@@ -9256,7 +9256,7 @@
           <a:p>
             <a:pPr algn="l"/>
             <a:r>
-              <a:rPr sz="3600" b="1">
+              <a:rPr sz="2600" b="1">
                 <a:solidFill>
                   <a:srgbClr val="FFFFFF"/>
                 </a:solidFill>
@@ -9319,7 +9319,7 @@
       </p:sp>
       <p:sp>
         <p:nvSpPr>
-          <p:cNvPr id="9" name="Rounded Rectangle 8"/>
+          <p:cNvPr id="9" name="Rectangle 8"/>
           <p:cNvSpPr/>
           <p:nvPr/>
         </p:nvSpPr>
@@ -9339,7 +9339,7 @@
             <a:off x="676656" y="1522476"/>
             <a:ext cx="3496056" cy="4494276"/>
           </a:xfrm>
-          <a:prstGeom prst="roundRect">
+          <a:prstGeom prst="rect">
             <a:avLst/>
           </a:prstGeom>
           <a:ln>
@@ -9460,7 +9460,7 @@
       </p:sp>
       <p:sp>
         <p:nvSpPr>
-          <p:cNvPr id="12" name="Rounded Rectangle 11"/>
+          <p:cNvPr id="12" name="Rectangle 11"/>
           <p:cNvSpPr/>
           <p:nvPr/>
         </p:nvSpPr>
@@ -9480,7 +9480,7 @@
             <a:off x="4309872" y="1522476"/>
             <a:ext cx="3496056" cy="4494276"/>
           </a:xfrm>
-          <a:prstGeom prst="roundRect">
+          <a:prstGeom prst="rect">
             <a:avLst/>
           </a:prstGeom>
           <a:ln>
@@ -9601,7 +9601,7 @@
       </p:sp>
       <p:sp>
         <p:nvSpPr>
-          <p:cNvPr id="15" name="Rounded Rectangle 14"/>
+          <p:cNvPr id="15" name="Rectangle 14"/>
           <p:cNvSpPr/>
           <p:nvPr/>
         </p:nvSpPr>
@@ -9621,7 +9621,7 @@
             <a:off x="7943088" y="1522476"/>
             <a:ext cx="3496056" cy="4494276"/>
           </a:xfrm>
-          <a:prstGeom prst="roundRect">
+          <a:prstGeom prst="rect">
             <a:avLst/>
           </a:prstGeom>
           <a:ln>
@@ -9826,7 +9826,7 @@
             <a:r>
               <a:rPr sz="13000" b="1">
                 <a:solidFill>
-                  <a:srgbClr val="C2EAE8"/>
+                  <a:srgbClr val="D8F0EF"/>
                 </a:solidFill>
               </a:rPr>
               <a:t>UP</a:t>
@@ -10038,7 +10038,7 @@
           <a:p>
             <a:pPr algn="l"/>
             <a:r>
-              <a:rPr sz="3600" b="1">
+              <a:rPr sz="2600" b="1">
                 <a:solidFill>
                   <a:srgbClr val="FFFFFF"/>
                 </a:solidFill>
@@ -10135,7 +10135,7 @@
       </p:sp>
       <p:sp>
         <p:nvSpPr>
-          <p:cNvPr id="10" name="Rounded Rectangle 9"/>
+          <p:cNvPr id="10" name="Rectangle 9"/>
           <p:cNvSpPr/>
           <p:nvPr/>
         </p:nvSpPr>
@@ -10155,7 +10155,7 @@
             <a:off x="630936" y="2043684"/>
             <a:ext cx="4022354" cy="4384548"/>
           </a:xfrm>
-          <a:prstGeom prst="roundRect">
+          <a:prstGeom prst="rect">
             <a:avLst/>
           </a:prstGeom>
           <a:ln>
@@ -12090,7 +12090,7 @@
             <a:r>
               <a:rPr sz="13000" b="1">
                 <a:solidFill>
-                  <a:srgbClr val="C2EAE8"/>
+                  <a:srgbClr val="D8F0EF"/>
                 </a:solidFill>
               </a:rPr>
               <a:t>#1</a:t>
@@ -12302,7 +12302,7 @@
           <a:p>
             <a:pPr algn="l"/>
             <a:r>
-              <a:rPr sz="3600" b="1">
+              <a:rPr sz="2600" b="1">
                 <a:solidFill>
                   <a:srgbClr val="FFFFFF"/>
                 </a:solidFill>
@@ -12399,7 +12399,7 @@
       </p:sp>
       <p:sp>
         <p:nvSpPr>
-          <p:cNvPr id="10" name="Rounded Rectangle 9"/>
+          <p:cNvPr id="10" name="Rectangle 9"/>
           <p:cNvSpPr/>
           <p:nvPr/>
         </p:nvSpPr>
@@ -12419,7 +12419,7 @@
             <a:off x="630936" y="2034540"/>
             <a:ext cx="640080" cy="834847"/>
           </a:xfrm>
-          <a:prstGeom prst="roundRect">
+          <a:prstGeom prst="rect">
             <a:avLst/>
           </a:prstGeom>
           <a:ln>
@@ -12603,7 +12603,7 @@
       </p:sp>
       <p:sp>
         <p:nvSpPr>
-          <p:cNvPr id="15" name="Rounded Rectangle 14"/>
+          <p:cNvPr id="15" name="Rectangle 14"/>
           <p:cNvSpPr/>
           <p:nvPr/>
         </p:nvSpPr>
@@ -12623,7 +12623,7 @@
             <a:off x="630936" y="2979115"/>
             <a:ext cx="640080" cy="834847"/>
           </a:xfrm>
-          <a:prstGeom prst="roundRect">
+          <a:prstGeom prst="rect">
             <a:avLst/>
           </a:prstGeom>
           <a:ln>
@@ -12807,7 +12807,7 @@
       </p:sp>
       <p:sp>
         <p:nvSpPr>
-          <p:cNvPr id="20" name="Rounded Rectangle 19"/>
+          <p:cNvPr id="20" name="Rectangle 19"/>
           <p:cNvSpPr/>
           <p:nvPr/>
         </p:nvSpPr>
@@ -12827,7 +12827,7 @@
             <a:off x="630936" y="3923690"/>
             <a:ext cx="640080" cy="834847"/>
           </a:xfrm>
-          <a:prstGeom prst="roundRect">
+          <a:prstGeom prst="rect">
             <a:avLst/>
           </a:prstGeom>
           <a:ln>
@@ -13011,7 +13011,7 @@
       </p:sp>
       <p:sp>
         <p:nvSpPr>
-          <p:cNvPr id="25" name="Rounded Rectangle 24"/>
+          <p:cNvPr id="25" name="Rectangle 24"/>
           <p:cNvSpPr/>
           <p:nvPr/>
         </p:nvSpPr>
@@ -13031,7 +13031,7 @@
             <a:off x="630936" y="4868265"/>
             <a:ext cx="640080" cy="834847"/>
           </a:xfrm>
-          <a:prstGeom prst="roundRect">
+          <a:prstGeom prst="rect">
             <a:avLst/>
           </a:prstGeom>
           <a:ln>
@@ -13215,7 +13215,7 @@
       </p:sp>
       <p:sp>
         <p:nvSpPr>
-          <p:cNvPr id="30" name="Rounded Rectangle 29"/>
+          <p:cNvPr id="30" name="Rectangle 29"/>
           <p:cNvSpPr/>
           <p:nvPr/>
         </p:nvSpPr>
@@ -13235,7 +13235,7 @@
             <a:off x="630936" y="5812840"/>
             <a:ext cx="640080" cy="834847"/>
           </a:xfrm>
-          <a:prstGeom prst="roundRect">
+          <a:prstGeom prst="rect">
             <a:avLst/>
           </a:prstGeom>
           <a:ln>
@@ -14909,7 +14909,7 @@
             <a:r>
               <a:rPr sz="13000" b="1">
                 <a:solidFill>
-                  <a:srgbClr val="C2EAE8"/>
+                  <a:srgbClr val="D8F0EF"/>
                 </a:solidFill>
               </a:rPr>
               <a:t>GROW</a:t>
@@ -15121,7 +15121,7 @@
           <a:p>
             <a:pPr algn="l"/>
             <a:r>
-              <a:rPr sz="3600" b="1">
+              <a:rPr sz="2600" b="1">
                 <a:solidFill>
                   <a:srgbClr val="FFFFFF"/>
                 </a:solidFill>
@@ -15218,7 +15218,7 @@
       </p:sp>
       <p:sp>
         <p:nvSpPr>
-          <p:cNvPr id="10" name="Rounded Rectangle 9"/>
+          <p:cNvPr id="10" name="Rectangle 9"/>
           <p:cNvSpPr/>
           <p:nvPr/>
         </p:nvSpPr>
@@ -15238,7 +15238,7 @@
             <a:off x="630936" y="2071116"/>
             <a:ext cx="4875580" cy="4402836"/>
           </a:xfrm>
-          <a:prstGeom prst="roundRect">
+          <a:prstGeom prst="rect">
             <a:avLst/>
           </a:prstGeom>
           <a:ln>
@@ -16495,7 +16495,7 @@
             <a:r>
               <a:rPr sz="13000" b="1">
                 <a:solidFill>
-                  <a:srgbClr val="C2EAE8"/>
+                  <a:srgbClr val="D8F0EF"/>
                 </a:solidFill>
               </a:rPr>
               <a:t>→</a:t>
@@ -16707,7 +16707,7 @@
           <a:p>
             <a:pPr algn="l"/>
             <a:r>
-              <a:rPr sz="3600" b="1">
+              <a:rPr sz="2600" b="1">
                 <a:solidFill>
                   <a:srgbClr val="FFFFFF"/>
                 </a:solidFill>
@@ -17017,7 +17017,7 @@
       </p:sp>
       <p:sp>
         <p:nvSpPr>
-          <p:cNvPr id="16" name="Rounded Rectangle 15"/>
+          <p:cNvPr id="16" name="Rectangle 15"/>
           <p:cNvSpPr/>
           <p:nvPr/>
         </p:nvSpPr>
@@ -17037,7 +17037,7 @@
             <a:off x="6286500" y="1458468"/>
             <a:ext cx="5765292" cy="4997196"/>
           </a:xfrm>
-          <a:prstGeom prst="roundRect">
+          <a:prstGeom prst="rect">
             <a:avLst/>
           </a:prstGeom>
           <a:ln>
@@ -17322,7 +17322,7 @@
             <a:r>
               <a:rPr sz="13000" b="1">
                 <a:solidFill>
-                  <a:srgbClr val="C2EAE8"/>
+                  <a:srgbClr val="D8F0EF"/>
                 </a:solidFill>
               </a:rPr>
               <a:t>WHY</a:t>
@@ -17534,7 +17534,7 @@
           <a:p>
             <a:pPr algn="l"/>
             <a:r>
-              <a:rPr sz="3600" b="1">
+              <a:rPr sz="2600" b="1">
                 <a:solidFill>
                   <a:srgbClr val="FFFFFF"/>
                 </a:solidFill>
@@ -17597,7 +17597,7 @@
       </p:sp>
       <p:sp>
         <p:nvSpPr>
-          <p:cNvPr id="9" name="Rounded Rectangle 8"/>
+          <p:cNvPr id="9" name="Rectangle 8"/>
           <p:cNvSpPr/>
           <p:nvPr/>
         </p:nvSpPr>
@@ -17617,7 +17617,7 @@
             <a:off x="676656" y="1495044"/>
             <a:ext cx="3496056" cy="4796028"/>
           </a:xfrm>
-          <a:prstGeom prst="roundRect">
+          <a:prstGeom prst="rect">
             <a:avLst/>
           </a:prstGeom>
           <a:ln>
@@ -17772,7 +17772,7 @@
       </p:sp>
       <p:sp>
         <p:nvSpPr>
-          <p:cNvPr id="13" name="Rounded Rectangle 12"/>
+          <p:cNvPr id="13" name="Rectangle 12"/>
           <p:cNvSpPr/>
           <p:nvPr/>
         </p:nvSpPr>
@@ -17792,7 +17792,7 @@
             <a:off x="4309872" y="1495044"/>
             <a:ext cx="3496056" cy="4796028"/>
           </a:xfrm>
-          <a:prstGeom prst="roundRect">
+          <a:prstGeom prst="rect">
             <a:avLst/>
           </a:prstGeom>
           <a:ln>
@@ -17947,7 +17947,7 @@
       </p:sp>
       <p:sp>
         <p:nvSpPr>
-          <p:cNvPr id="17" name="Rounded Rectangle 16"/>
+          <p:cNvPr id="17" name="Rectangle 16"/>
           <p:cNvSpPr/>
           <p:nvPr/>
         </p:nvSpPr>
@@ -17967,7 +17967,7 @@
             <a:off x="7943088" y="1495044"/>
             <a:ext cx="3496056" cy="4796028"/>
           </a:xfrm>
-          <a:prstGeom prst="roundRect">
+          <a:prstGeom prst="rect">
             <a:avLst/>
           </a:prstGeom>
           <a:ln>
@@ -18172,7 +18172,7 @@
             <a:r>
               <a:rPr sz="13000" b="1">
                 <a:solidFill>
-                  <a:srgbClr val="C2EAE8"/>
+                  <a:srgbClr val="D8F0EF"/>
                 </a:solidFill>
               </a:rPr>
               <a:t>PLAN</a:t>
@@ -18384,7 +18384,7 @@
           <a:p>
             <a:pPr algn="l"/>
             <a:r>
-              <a:rPr sz="3600" b="1">
+              <a:rPr sz="2600" b="1">
                 <a:solidFill>
                   <a:srgbClr val="FFFFFF"/>
                 </a:solidFill>
@@ -18447,7 +18447,7 @@
       </p:sp>
       <p:sp>
         <p:nvSpPr>
-          <p:cNvPr id="9" name="Rounded Rectangle 8"/>
+          <p:cNvPr id="9" name="Rectangle 8"/>
           <p:cNvSpPr/>
           <p:nvPr/>
         </p:nvSpPr>
@@ -18467,7 +18467,7 @@
             <a:off x="676656" y="1458468"/>
             <a:ext cx="3496056" cy="2361438"/>
           </a:xfrm>
-          <a:prstGeom prst="roundRect">
+          <a:prstGeom prst="rect">
             <a:avLst/>
           </a:prstGeom>
           <a:ln>
@@ -18588,7 +18588,7 @@
       </p:sp>
       <p:sp>
         <p:nvSpPr>
-          <p:cNvPr id="12" name="Rounded Rectangle 11"/>
+          <p:cNvPr id="12" name="Rectangle 11"/>
           <p:cNvSpPr/>
           <p:nvPr/>
         </p:nvSpPr>
@@ -18608,7 +18608,7 @@
             <a:off x="4309872" y="1458468"/>
             <a:ext cx="3496056" cy="2361438"/>
           </a:xfrm>
-          <a:prstGeom prst="roundRect">
+          <a:prstGeom prst="rect">
             <a:avLst/>
           </a:prstGeom>
           <a:ln>
@@ -18729,7 +18729,7 @@
       </p:sp>
       <p:sp>
         <p:nvSpPr>
-          <p:cNvPr id="15" name="Rounded Rectangle 14"/>
+          <p:cNvPr id="15" name="Rectangle 14"/>
           <p:cNvSpPr/>
           <p:nvPr/>
         </p:nvSpPr>
@@ -18749,7 +18749,7 @@
             <a:off x="7943088" y="1458468"/>
             <a:ext cx="3496056" cy="2361438"/>
           </a:xfrm>
-          <a:prstGeom prst="roundRect">
+          <a:prstGeom prst="rect">
             <a:avLst/>
           </a:prstGeom>
           <a:ln>
@@ -18870,7 +18870,7 @@
       </p:sp>
       <p:sp>
         <p:nvSpPr>
-          <p:cNvPr id="18" name="Rounded Rectangle 17"/>
+          <p:cNvPr id="18" name="Rectangle 17"/>
           <p:cNvSpPr/>
           <p:nvPr/>
         </p:nvSpPr>
@@ -18890,7 +18890,7 @@
             <a:off x="676656" y="3957066"/>
             <a:ext cx="3496056" cy="2361438"/>
           </a:xfrm>
-          <a:prstGeom prst="roundRect">
+          <a:prstGeom prst="rect">
             <a:avLst/>
           </a:prstGeom>
           <a:ln>
@@ -19011,7 +19011,7 @@
       </p:sp>
       <p:sp>
         <p:nvSpPr>
-          <p:cNvPr id="21" name="Rounded Rectangle 20"/>
+          <p:cNvPr id="21" name="Rectangle 20"/>
           <p:cNvSpPr/>
           <p:nvPr/>
         </p:nvSpPr>
@@ -19031,7 +19031,7 @@
             <a:off x="4309872" y="3957066"/>
             <a:ext cx="3496056" cy="2361438"/>
           </a:xfrm>
-          <a:prstGeom prst="roundRect">
+          <a:prstGeom prst="rect">
             <a:avLst/>
           </a:prstGeom>
           <a:ln>
@@ -19152,7 +19152,7 @@
       </p:sp>
       <p:sp>
         <p:nvSpPr>
-          <p:cNvPr id="24" name="Rounded Rectangle 23"/>
+          <p:cNvPr id="24" name="Rectangle 23"/>
           <p:cNvSpPr/>
           <p:nvPr/>
         </p:nvSpPr>
@@ -19172,7 +19172,7 @@
             <a:off x="7943088" y="3957066"/>
             <a:ext cx="3496056" cy="2361438"/>
           </a:xfrm>
-          <a:prstGeom prst="roundRect">
+          <a:prstGeom prst="rect">
             <a:avLst/>
           </a:prstGeom>
           <a:ln>
@@ -19343,7 +19343,7 @@
             <a:r>
               <a:rPr sz="13000" b="1">
                 <a:solidFill>
-                  <a:srgbClr val="C2EAE8"/>
+                  <a:srgbClr val="D8F0EF"/>
                 </a:solidFill>
               </a:rPr>
               <a:t>GOAL</a:t>
@@ -19555,7 +19555,7 @@
           <a:p>
             <a:pPr algn="l"/>
             <a:r>
-              <a:rPr sz="3600" b="1">
+              <a:rPr sz="2600" b="1">
                 <a:solidFill>
                   <a:srgbClr val="FFFFFF"/>
                 </a:solidFill>
@@ -19618,7 +19618,7 @@
       </p:sp>
       <p:sp>
         <p:nvSpPr>
-          <p:cNvPr id="9" name="Rounded Rectangle 8"/>
+          <p:cNvPr id="9" name="Rectangle 8"/>
           <p:cNvSpPr/>
           <p:nvPr/>
         </p:nvSpPr>
@@ -19638,7 +19638,7 @@
             <a:off x="676656" y="1458468"/>
             <a:ext cx="5312664" cy="2379726"/>
           </a:xfrm>
-          <a:prstGeom prst="roundRect">
+          <a:prstGeom prst="rect">
             <a:avLst/>
           </a:prstGeom>
           <a:ln>
@@ -19805,7 +19805,7 @@
       </p:sp>
       <p:sp>
         <p:nvSpPr>
-          <p:cNvPr id="14" name="Rounded Rectangle 13"/>
+          <p:cNvPr id="14" name="Rectangle 13"/>
           <p:cNvSpPr/>
           <p:nvPr/>
         </p:nvSpPr>
@@ -19825,7 +19825,7 @@
             <a:off x="6126480" y="1458468"/>
             <a:ext cx="5312664" cy="2379726"/>
           </a:xfrm>
-          <a:prstGeom prst="roundRect">
+          <a:prstGeom prst="rect">
             <a:avLst/>
           </a:prstGeom>
           <a:ln>
@@ -19992,7 +19992,7 @@
       </p:sp>
       <p:sp>
         <p:nvSpPr>
-          <p:cNvPr id="19" name="Rounded Rectangle 18"/>
+          <p:cNvPr id="19" name="Rectangle 18"/>
           <p:cNvSpPr/>
           <p:nvPr/>
         </p:nvSpPr>
@@ -20012,7 +20012,7 @@
             <a:off x="676656" y="4002786"/>
             <a:ext cx="5312664" cy="2379726"/>
           </a:xfrm>
-          <a:prstGeom prst="roundRect">
+          <a:prstGeom prst="rect">
             <a:avLst/>
           </a:prstGeom>
           <a:ln>
@@ -20179,7 +20179,7 @@
       </p:sp>
       <p:sp>
         <p:nvSpPr>
-          <p:cNvPr id="24" name="Rounded Rectangle 23"/>
+          <p:cNvPr id="24" name="Rectangle 23"/>
           <p:cNvSpPr/>
           <p:nvPr/>
         </p:nvSpPr>
@@ -20199,7 +20199,7 @@
             <a:off x="6126480" y="4002786"/>
             <a:ext cx="5312664" cy="2379726"/>
           </a:xfrm>
-          <a:prstGeom prst="roundRect">
+          <a:prstGeom prst="rect">
             <a:avLst/>
           </a:prstGeom>
           <a:ln>
@@ -20416,7 +20416,7 @@
             <a:r>
               <a:rPr sz="13000" b="1">
                 <a:solidFill>
-                  <a:srgbClr val="C2EAE8"/>
+                  <a:srgbClr val="D8F0EF"/>
                 </a:solidFill>
               </a:rPr>
               <a:t>VS</a:t>
@@ -20628,7 +20628,7 @@
           <a:p>
             <a:pPr algn="l"/>
             <a:r>
-              <a:rPr sz="3600" b="1">
+              <a:rPr sz="2600" b="1">
                 <a:solidFill>
                   <a:srgbClr val="FFFFFF"/>
                 </a:solidFill>
@@ -22554,7 +22554,7 @@
       </p:sp>
       <p:sp>
         <p:nvSpPr>
-          <p:cNvPr id="12" name="Rounded Rectangle 11"/>
+          <p:cNvPr id="12" name="Rectangle 11"/>
           <p:cNvSpPr/>
           <p:nvPr/>
         </p:nvSpPr>
@@ -22574,7 +22574,7 @@
             <a:off x="950976" y="4766310"/>
             <a:ext cx="10287000" cy="1508760"/>
           </a:xfrm>
-          <a:prstGeom prst="roundRect">
+          <a:prstGeom prst="rect">
             <a:avLst/>
           </a:prstGeom>
           <a:ln>
@@ -23086,7 +23086,7 @@
       </p:sp>
       <p:sp>
         <p:nvSpPr>
-          <p:cNvPr id="12" name="Rounded Rectangle 11"/>
+          <p:cNvPr id="12" name="Rectangle 11"/>
           <p:cNvSpPr/>
           <p:nvPr/>
         </p:nvSpPr>
@@ -23106,7 +23106,7 @@
             <a:off x="594360" y="5623560"/>
             <a:ext cx="6338255" cy="658368"/>
           </a:xfrm>
-          <a:prstGeom prst="roundRect">
+          <a:prstGeom prst="rect">
             <a:avLst/>
           </a:prstGeom>
           <a:ln>
@@ -23221,7 +23221,7 @@
             <a:r>
               <a:rPr sz="13000" b="1">
                 <a:solidFill>
-                  <a:srgbClr val="C2EAE8"/>
+                  <a:srgbClr val="D8F0EF"/>
                 </a:solidFill>
               </a:rPr>
               <a:t>MAP</a:t>
@@ -23433,7 +23433,7 @@
           <a:p>
             <a:pPr algn="l"/>
             <a:r>
-              <a:rPr sz="3600" b="1">
+              <a:rPr sz="2600" b="1">
                 <a:solidFill>
                   <a:srgbClr val="FFFFFF"/>
                 </a:solidFill>
@@ -23496,7 +23496,7 @@
       </p:sp>
       <p:sp>
         <p:nvSpPr>
-          <p:cNvPr id="9" name="Rounded Rectangle 8"/>
+          <p:cNvPr id="9" name="Rectangle 8"/>
           <p:cNvSpPr/>
           <p:nvPr/>
         </p:nvSpPr>
@@ -23516,7 +23516,7 @@
             <a:off x="676656" y="1549908"/>
             <a:ext cx="2587752" cy="4631436"/>
           </a:xfrm>
-          <a:prstGeom prst="roundRect">
+          <a:prstGeom prst="rect">
             <a:avLst/>
           </a:prstGeom>
           <a:ln>
@@ -23660,7 +23660,7 @@
       </p:sp>
       <p:sp>
         <p:nvSpPr>
-          <p:cNvPr id="13" name="Rounded Rectangle 12"/>
+          <p:cNvPr id="13" name="Rectangle 12"/>
           <p:cNvSpPr/>
           <p:nvPr/>
         </p:nvSpPr>
@@ -23680,7 +23680,7 @@
             <a:off x="3401568" y="1549908"/>
             <a:ext cx="2587752" cy="4631436"/>
           </a:xfrm>
-          <a:prstGeom prst="roundRect">
+          <a:prstGeom prst="rect">
             <a:avLst/>
           </a:prstGeom>
           <a:ln>
@@ -23824,7 +23824,7 @@
       </p:sp>
       <p:sp>
         <p:nvSpPr>
-          <p:cNvPr id="17" name="Rounded Rectangle 16"/>
+          <p:cNvPr id="17" name="Rectangle 16"/>
           <p:cNvSpPr/>
           <p:nvPr/>
         </p:nvSpPr>
@@ -23844,7 +23844,7 @@
             <a:off x="6126480" y="1549908"/>
             <a:ext cx="2587752" cy="4631436"/>
           </a:xfrm>
-          <a:prstGeom prst="roundRect">
+          <a:prstGeom prst="rect">
             <a:avLst/>
           </a:prstGeom>
           <a:ln>
@@ -23988,7 +23988,7 @@
       </p:sp>
       <p:sp>
         <p:nvSpPr>
-          <p:cNvPr id="21" name="Rounded Rectangle 20"/>
+          <p:cNvPr id="21" name="Rectangle 20"/>
           <p:cNvSpPr/>
           <p:nvPr/>
         </p:nvSpPr>
@@ -24008,7 +24008,7 @@
             <a:off x="8851392" y="1549908"/>
             <a:ext cx="2587752" cy="4631436"/>
           </a:xfrm>
-          <a:prstGeom prst="roundRect">
+          <a:prstGeom prst="rect">
             <a:avLst/>
           </a:prstGeom>
           <a:ln>
@@ -24236,7 +24236,7 @@
             <a:r>
               <a:rPr sz="13000" b="1">
                 <a:solidFill>
-                  <a:srgbClr val="C2EAE8"/>
+                  <a:srgbClr val="D8F0EF"/>
                 </a:solidFill>
               </a:rPr>
               <a:t>TOP</a:t>
@@ -24448,7 +24448,7 @@
           <a:p>
             <a:pPr algn="l"/>
             <a:r>
-              <a:rPr sz="3600" b="1">
+              <a:rPr sz="2600" b="1">
                 <a:solidFill>
                   <a:srgbClr val="FFFFFF"/>
                 </a:solidFill>
@@ -24511,7 +24511,7 @@
       </p:sp>
       <p:sp>
         <p:nvSpPr>
-          <p:cNvPr id="9" name="Rounded Rectangle 8"/>
+          <p:cNvPr id="9" name="Rectangle 8"/>
           <p:cNvSpPr/>
           <p:nvPr/>
         </p:nvSpPr>
@@ -24531,7 +24531,7 @@
             <a:off x="539496" y="1476756"/>
             <a:ext cx="4631801" cy="5116068"/>
           </a:xfrm>
-          <a:prstGeom prst="roundRect">
+          <a:prstGeom prst="rect">
             <a:avLst/>
           </a:prstGeom>
           <a:ln>
@@ -24777,7 +24777,7 @@
       </p:sp>
       <p:sp>
         <p:nvSpPr>
-          <p:cNvPr id="16" name="Rounded Rectangle 15"/>
+          <p:cNvPr id="16" name="Rectangle 15"/>
           <p:cNvSpPr/>
           <p:nvPr/>
         </p:nvSpPr>
@@ -24797,7 +24797,7 @@
             <a:off x="5658855" y="1476756"/>
             <a:ext cx="5963168" cy="1325880"/>
           </a:xfrm>
-          <a:prstGeom prst="roundRect">
+          <a:prstGeom prst="rect">
             <a:avLst/>
           </a:prstGeom>
           <a:ln>
@@ -24930,7 +24930,7 @@
       </p:sp>
       <p:sp>
         <p:nvSpPr>
-          <p:cNvPr id="20" name="Rounded Rectangle 19"/>
+          <p:cNvPr id="20" name="Rectangle 19"/>
           <p:cNvSpPr/>
           <p:nvPr/>
         </p:nvSpPr>
@@ -24950,7 +24950,7 @@
             <a:off x="5658855" y="2967228"/>
             <a:ext cx="5963168" cy="1325880"/>
           </a:xfrm>
-          <a:prstGeom prst="roundRect">
+          <a:prstGeom prst="rect">
             <a:avLst/>
           </a:prstGeom>
           <a:ln>
@@ -25083,7 +25083,7 @@
       </p:sp>
       <p:sp>
         <p:nvSpPr>
-          <p:cNvPr id="24" name="Rounded Rectangle 23"/>
+          <p:cNvPr id="24" name="Rectangle 23"/>
           <p:cNvSpPr/>
           <p:nvPr/>
         </p:nvSpPr>
@@ -25103,7 +25103,7 @@
             <a:off x="5658855" y="4457700"/>
             <a:ext cx="5963168" cy="1325880"/>
           </a:xfrm>
-          <a:prstGeom prst="roundRect">
+          <a:prstGeom prst="rect">
             <a:avLst/>
           </a:prstGeom>
           <a:ln>
@@ -25286,7 +25286,7 @@
             <a:r>
               <a:rPr sz="13000" b="1">
                 <a:solidFill>
-                  <a:srgbClr val="C2EAE8"/>
+                  <a:srgbClr val="D8F0EF"/>
                 </a:solidFill>
               </a:rPr>
               <a:t>¥</a:t>
@@ -25498,7 +25498,7 @@
           <a:p>
             <a:pPr algn="l"/>
             <a:r>
-              <a:rPr sz="3600" b="1">
+              <a:rPr sz="2600" b="1">
                 <a:solidFill>
                   <a:srgbClr val="FFFFFF"/>
                 </a:solidFill>
@@ -25561,7 +25561,7 @@
       </p:sp>
       <p:sp>
         <p:nvSpPr>
-          <p:cNvPr id="9" name="Rounded Rectangle 8"/>
+          <p:cNvPr id="9" name="Rectangle 8"/>
           <p:cNvSpPr/>
           <p:nvPr/>
         </p:nvSpPr>
@@ -25581,7 +25581,7 @@
             <a:off x="722376" y="1495044"/>
             <a:ext cx="3438144" cy="4631436"/>
           </a:xfrm>
-          <a:prstGeom prst="roundRect">
+          <a:prstGeom prst="rect">
             <a:avLst/>
           </a:prstGeom>
           <a:ln>
@@ -25747,7 +25747,7 @@
       </p:sp>
       <p:sp>
         <p:nvSpPr>
-          <p:cNvPr id="13" name="Rounded Rectangle 12"/>
+          <p:cNvPr id="13" name="Rectangle 12"/>
           <p:cNvSpPr/>
           <p:nvPr/>
         </p:nvSpPr>
@@ -25767,7 +25767,7 @@
             <a:off x="4325112" y="1495044"/>
             <a:ext cx="3438144" cy="4631436"/>
           </a:xfrm>
-          <a:prstGeom prst="roundRect">
+          <a:prstGeom prst="rect">
             <a:avLst/>
           </a:prstGeom>
           <a:ln>
@@ -25933,7 +25933,7 @@
       </p:sp>
       <p:sp>
         <p:nvSpPr>
-          <p:cNvPr id="17" name="Rounded Rectangle 16"/>
+          <p:cNvPr id="17" name="Rectangle 16"/>
           <p:cNvSpPr/>
           <p:nvPr/>
         </p:nvSpPr>
@@ -25953,7 +25953,7 @@
             <a:off x="7927848" y="1495044"/>
             <a:ext cx="3438144" cy="4631436"/>
           </a:xfrm>
-          <a:prstGeom prst="roundRect">
+          <a:prstGeom prst="rect">
             <a:avLst/>
           </a:prstGeom>
           <a:ln>
@@ -27092,7 +27092,7 @@
             <a:r>
               <a:rPr sz="13000" b="1">
                 <a:solidFill>
-                  <a:srgbClr val="C2EAE8"/>
+                  <a:srgbClr val="D8F0EF"/>
                 </a:solidFill>
               </a:rPr>
               <a:t>vs</a:t>
@@ -27304,7 +27304,7 @@
           <a:p>
             <a:pPr algn="l"/>
             <a:r>
-              <a:rPr sz="3600" b="1">
+              <a:rPr sz="2600" b="1">
                 <a:solidFill>
                   <a:srgbClr val="FFFFFF"/>
                 </a:solidFill>
@@ -27648,7 +27648,7 @@
       </p:sp>
       <p:sp>
         <p:nvSpPr>
-          <p:cNvPr id="17" name="Rounded Rectangle 16"/>
+          <p:cNvPr id="17" name="Rectangle 16"/>
           <p:cNvSpPr/>
           <p:nvPr/>
         </p:nvSpPr>
@@ -27668,7 +27668,7 @@
             <a:off x="6286500" y="1458468"/>
             <a:ext cx="5765292" cy="5042916"/>
           </a:xfrm>
-          <a:prstGeom prst="roundRect">
+          <a:prstGeom prst="rect">
             <a:avLst/>
           </a:prstGeom>
           <a:ln>
@@ -27987,7 +27987,7 @@
             <a:r>
               <a:rPr sz="13000" b="1">
                 <a:solidFill>
-                  <a:srgbClr val="C2EAE8"/>
+                  <a:srgbClr val="D8F0EF"/>
                 </a:solidFill>
               </a:rPr>
               <a:t>UP</a:t>
@@ -28199,7 +28199,7 @@
           <a:p>
             <a:pPr algn="l"/>
             <a:r>
-              <a:rPr sz="3600" b="1">
+              <a:rPr sz="2600" b="1">
                 <a:solidFill>
                   <a:srgbClr val="FFFFFF"/>
                 </a:solidFill>
@@ -28418,7 +28418,7 @@
       </p:sp>
       <p:sp>
         <p:nvSpPr>
-          <p:cNvPr id="13" name="Rounded Rectangle 12"/>
+          <p:cNvPr id="13" name="Rectangle 12"/>
           <p:cNvSpPr/>
           <p:nvPr/>
         </p:nvSpPr>
@@ -28438,7 +28438,7 @@
             <a:off x="3424428" y="1829257"/>
             <a:ext cx="2683764" cy="4214926"/>
           </a:xfrm>
-          <a:prstGeom prst="roundRect">
+          <a:prstGeom prst="rect">
             <a:avLst/>
           </a:prstGeom>
           <a:ln>
@@ -28582,7 +28582,7 @@
       </p:sp>
       <p:sp>
         <p:nvSpPr>
-          <p:cNvPr id="17" name="Rounded Rectangle 16"/>
+          <p:cNvPr id="17" name="Rectangle 16"/>
           <p:cNvSpPr/>
           <p:nvPr/>
         </p:nvSpPr>
@@ -28602,7 +28602,7 @@
             <a:off x="6217920" y="2108606"/>
             <a:ext cx="2683764" cy="3935577"/>
           </a:xfrm>
-          <a:prstGeom prst="roundRect">
+          <a:prstGeom prst="rect">
             <a:avLst/>
           </a:prstGeom>
           <a:ln>
@@ -28952,7 +28952,7 @@
             <a:r>
               <a:rPr sz="13000" b="1">
                 <a:solidFill>
-                  <a:srgbClr val="C2EAE8"/>
+                  <a:srgbClr val="D8F0EF"/>
                 </a:solidFill>
               </a:rPr>
               <a:t>×3</a:t>
@@ -29164,7 +29164,7 @@
           <a:p>
             <a:pPr algn="l"/>
             <a:r>
-              <a:rPr sz="3600" b="1">
+              <a:rPr sz="2600" b="1">
                 <a:solidFill>
                   <a:srgbClr val="FFFFFF"/>
                 </a:solidFill>

</xml_diff>

<commit_message>
auto: update 2026-04-27 16:37:09
</commit_message>
<xml_diff>
--- a/08【MEO対策エンド資料デザイン化】/MEO対策エンド資料_v5.pptx
+++ b/08【MEO対策エンド資料デザイン化】/MEO対策エンド資料_v5.pptx
@@ -3533,17 +3533,6 @@
           <p:nvPr/>
         </p:nvSpPr>
         <p:spPr>
-          <a:gradFill>
-            <a:gsLst>
-              <a:gs pos="0">
-                <a:srgbClr val="005E6E"/>
-              </a:gs>
-              <a:gs pos="100000">
-                <a:srgbClr val="009A9A"/>
-              </a:gs>
-            </a:gsLst>
-            <a:lin ang="5400000" scaled="0"/>
-          </a:gradFill>
           <a:xfrm>
             <a:off x="6703923" y="5040630"/>
             <a:ext cx="4875580" cy="420624"/>
@@ -3551,6 +3540,9 @@
           <a:prstGeom prst="rect">
             <a:avLst/>
           </a:prstGeom>
+          <a:solidFill>
+            <a:srgbClr val="005E6E"/>
+          </a:solidFill>
           <a:ln>
             <a:noFill/>
           </a:ln>
@@ -3652,17 +3644,6 @@
           <p:nvPr/>
         </p:nvSpPr>
         <p:spPr>
-          <a:gradFill>
-            <a:gsLst>
-              <a:gs pos="0">
-                <a:srgbClr val="005E6E"/>
-              </a:gs>
-              <a:gs pos="100000">
-                <a:srgbClr val="009A9A"/>
-              </a:gs>
-            </a:gsLst>
-            <a:lin ang="5400000" scaled="0"/>
-          </a:gradFill>
           <a:xfrm>
             <a:off x="6703923" y="5543550"/>
             <a:ext cx="4875580" cy="420624"/>
@@ -3670,6 +3651,9 @@
           <a:prstGeom prst="rect">
             <a:avLst/>
           </a:prstGeom>
+          <a:solidFill>
+            <a:srgbClr val="005E6E"/>
+          </a:solidFill>
           <a:ln>
             <a:noFill/>
           </a:ln>
@@ -3771,17 +3755,6 @@
           <p:nvPr/>
         </p:nvSpPr>
         <p:spPr>
-          <a:gradFill>
-            <a:gsLst>
-              <a:gs pos="0">
-                <a:srgbClr val="005E6E"/>
-              </a:gs>
-              <a:gs pos="100000">
-                <a:srgbClr val="009A9A"/>
-              </a:gs>
-            </a:gsLst>
-            <a:lin ang="5400000" scaled="0"/>
-          </a:gradFill>
           <a:xfrm>
             <a:off x="6703923" y="6046470"/>
             <a:ext cx="4875580" cy="420624"/>
@@ -3789,6 +3762,9 @@
           <a:prstGeom prst="rect">
             <a:avLst/>
           </a:prstGeom>
+          <a:solidFill>
+            <a:srgbClr val="005E6E"/>
+          </a:solidFill>
           <a:ln>
             <a:noFill/>
           </a:ln>
@@ -4215,17 +4191,6 @@
           <p:nvPr/>
         </p:nvSpPr>
         <p:spPr>
-          <a:gradFill>
-            <a:gsLst>
-              <a:gs pos="0">
-                <a:srgbClr val="0A182C"/>
-              </a:gs>
-              <a:gs pos="100000">
-                <a:srgbClr val="005E6E"/>
-              </a:gs>
-            </a:gsLst>
-            <a:lin ang="16200000" scaled="0"/>
-          </a:gradFill>
           <a:xfrm>
             <a:off x="539496" y="1458468"/>
             <a:ext cx="4266133" cy="5134356"/>
@@ -4233,6 +4198,9 @@
           <a:prstGeom prst="rect">
             <a:avLst/>
           </a:prstGeom>
+          <a:solidFill>
+            <a:srgbClr val="0A182C"/>
+          </a:solidFill>
           <a:ln>
             <a:noFill/>
           </a:ln>
@@ -5069,17 +5037,6 @@
           <p:nvPr/>
         </p:nvSpPr>
         <p:spPr>
-          <a:gradFill>
-            <a:gsLst>
-              <a:gs pos="0">
-                <a:srgbClr val="005E6E"/>
-              </a:gs>
-              <a:gs pos="100000">
-                <a:srgbClr val="009A9A"/>
-              </a:gs>
-            </a:gsLst>
-            <a:lin ang="16200000" scaled="0"/>
-          </a:gradFill>
           <a:xfrm>
             <a:off x="676656" y="1495044"/>
             <a:ext cx="2587752" cy="4722876"/>
@@ -5087,6 +5044,9 @@
           <a:prstGeom prst="rect">
             <a:avLst/>
           </a:prstGeom>
+          <a:solidFill>
+            <a:srgbClr val="005E6E"/>
+          </a:solidFill>
           <a:ln>
             <a:noFill/>
           </a:ln>
@@ -5210,17 +5170,6 @@
           <p:nvPr/>
         </p:nvSpPr>
         <p:spPr>
-          <a:gradFill>
-            <a:gsLst>
-              <a:gs pos="0">
-                <a:srgbClr val="009A9A"/>
-              </a:gs>
-              <a:gs pos="100000">
-                <a:srgbClr val="00C4CC"/>
-              </a:gs>
-            </a:gsLst>
-            <a:lin ang="16200000" scaled="0"/>
-          </a:gradFill>
           <a:xfrm>
             <a:off x="3401568" y="1495044"/>
             <a:ext cx="2587752" cy="4722876"/>
@@ -5228,6 +5177,9 @@
           <a:prstGeom prst="rect">
             <a:avLst/>
           </a:prstGeom>
+          <a:solidFill>
+            <a:srgbClr val="009A9A"/>
+          </a:solidFill>
           <a:ln>
             <a:noFill/>
           </a:ln>
@@ -5351,17 +5303,6 @@
           <p:nvPr/>
         </p:nvSpPr>
         <p:spPr>
-          <a:gradFill>
-            <a:gsLst>
-              <a:gs pos="0">
-                <a:srgbClr val="00C4CC"/>
-              </a:gs>
-              <a:gs pos="100000">
-                <a:srgbClr val="3DD9E0"/>
-              </a:gs>
-            </a:gsLst>
-            <a:lin ang="16200000" scaled="0"/>
-          </a:gradFill>
           <a:xfrm>
             <a:off x="6126480" y="1495044"/>
             <a:ext cx="2587752" cy="4722876"/>
@@ -5369,6 +5310,9 @@
           <a:prstGeom prst="rect">
             <a:avLst/>
           </a:prstGeom>
+          <a:solidFill>
+            <a:srgbClr val="00C4CC"/>
+          </a:solidFill>
           <a:ln>
             <a:noFill/>
           </a:ln>
@@ -5492,17 +5436,6 @@
           <p:nvPr/>
         </p:nvSpPr>
         <p:spPr>
-          <a:gradFill>
-            <a:gsLst>
-              <a:gs pos="0">
-                <a:srgbClr val="009A9A"/>
-              </a:gs>
-              <a:gs pos="100000">
-                <a:srgbClr val="3DD9E0"/>
-              </a:gs>
-            </a:gsLst>
-            <a:lin ang="16200000" scaled="0"/>
-          </a:gradFill>
           <a:xfrm>
             <a:off x="8851392" y="1495044"/>
             <a:ext cx="2587752" cy="4722876"/>
@@ -5510,6 +5443,9 @@
           <a:prstGeom prst="rect">
             <a:avLst/>
           </a:prstGeom>
+          <a:solidFill>
+            <a:srgbClr val="009A9A"/>
+          </a:solidFill>
           <a:ln>
             <a:noFill/>
           </a:ln>
@@ -5958,17 +5894,6 @@
           <p:nvPr/>
         </p:nvSpPr>
         <p:spPr>
-          <a:gradFill>
-            <a:gsLst>
-              <a:gs pos="0">
-                <a:srgbClr val="005E6E"/>
-              </a:gs>
-              <a:gs pos="100000">
-                <a:srgbClr val="009A9A"/>
-              </a:gs>
-            </a:gsLst>
-            <a:lin ang="5400000" scaled="0"/>
-          </a:gradFill>
           <a:xfrm>
             <a:off x="676656" y="1476756"/>
             <a:ext cx="3496056" cy="2338578"/>
@@ -5976,6 +5901,9 @@
           <a:prstGeom prst="rect">
             <a:avLst/>
           </a:prstGeom>
+          <a:solidFill>
+            <a:srgbClr val="005E6E"/>
+          </a:solidFill>
           <a:ln>
             <a:noFill/>
           </a:ln>
@@ -6077,17 +6005,6 @@
           <p:nvPr/>
         </p:nvSpPr>
         <p:spPr>
-          <a:gradFill>
-            <a:gsLst>
-              <a:gs pos="0">
-                <a:srgbClr val="005E6E"/>
-              </a:gs>
-              <a:gs pos="100000">
-                <a:srgbClr val="009A9A"/>
-              </a:gs>
-            </a:gsLst>
-            <a:lin ang="5400000" scaled="0"/>
-          </a:gradFill>
           <a:xfrm>
             <a:off x="4309872" y="1476756"/>
             <a:ext cx="3496056" cy="2338578"/>
@@ -6095,6 +6012,9 @@
           <a:prstGeom prst="rect">
             <a:avLst/>
           </a:prstGeom>
+          <a:solidFill>
+            <a:srgbClr val="005E6E"/>
+          </a:solidFill>
           <a:ln>
             <a:noFill/>
           </a:ln>
@@ -6196,17 +6116,6 @@
           <p:nvPr/>
         </p:nvSpPr>
         <p:spPr>
-          <a:gradFill>
-            <a:gsLst>
-              <a:gs pos="0">
-                <a:srgbClr val="005E6E"/>
-              </a:gs>
-              <a:gs pos="100000">
-                <a:srgbClr val="009A9A"/>
-              </a:gs>
-            </a:gsLst>
-            <a:lin ang="5400000" scaled="0"/>
-          </a:gradFill>
           <a:xfrm>
             <a:off x="7943088" y="1476756"/>
             <a:ext cx="3496056" cy="2338578"/>
@@ -6214,6 +6123,9 @@
           <a:prstGeom prst="rect">
             <a:avLst/>
           </a:prstGeom>
+          <a:solidFill>
+            <a:srgbClr val="005E6E"/>
+          </a:solidFill>
           <a:ln>
             <a:noFill/>
           </a:ln>
@@ -6315,17 +6227,6 @@
           <p:nvPr/>
         </p:nvSpPr>
         <p:spPr>
-          <a:gradFill>
-            <a:gsLst>
-              <a:gs pos="0">
-                <a:srgbClr val="009A9A"/>
-              </a:gs>
-              <a:gs pos="100000">
-                <a:srgbClr val="00C4CC"/>
-              </a:gs>
-            </a:gsLst>
-            <a:lin ang="5400000" scaled="0"/>
-          </a:gradFill>
           <a:xfrm>
             <a:off x="676656" y="3952494"/>
             <a:ext cx="3496056" cy="2338578"/>
@@ -6333,6 +6234,9 @@
           <a:prstGeom prst="rect">
             <a:avLst/>
           </a:prstGeom>
+          <a:solidFill>
+            <a:srgbClr val="009A9A"/>
+          </a:solidFill>
           <a:ln>
             <a:noFill/>
           </a:ln>
@@ -6434,17 +6338,6 @@
           <p:nvPr/>
         </p:nvSpPr>
         <p:spPr>
-          <a:gradFill>
-            <a:gsLst>
-              <a:gs pos="0">
-                <a:srgbClr val="009A9A"/>
-              </a:gs>
-              <a:gs pos="100000">
-                <a:srgbClr val="00C4CC"/>
-              </a:gs>
-            </a:gsLst>
-            <a:lin ang="5400000" scaled="0"/>
-          </a:gradFill>
           <a:xfrm>
             <a:off x="4309872" y="3952494"/>
             <a:ext cx="3496056" cy="2338578"/>
@@ -6452,6 +6345,9 @@
           <a:prstGeom prst="rect">
             <a:avLst/>
           </a:prstGeom>
+          <a:solidFill>
+            <a:srgbClr val="009A9A"/>
+          </a:solidFill>
           <a:ln>
             <a:noFill/>
           </a:ln>
@@ -6553,17 +6449,6 @@
           <p:nvPr/>
         </p:nvSpPr>
         <p:spPr>
-          <a:gradFill>
-            <a:gsLst>
-              <a:gs pos="0">
-                <a:srgbClr val="009A9A"/>
-              </a:gs>
-              <a:gs pos="100000">
-                <a:srgbClr val="00C4CC"/>
-              </a:gs>
-            </a:gsLst>
-            <a:lin ang="5400000" scaled="0"/>
-          </a:gradFill>
           <a:xfrm>
             <a:off x="7943088" y="3952494"/>
             <a:ext cx="3496056" cy="2338578"/>
@@ -6571,6 +6456,9 @@
           <a:prstGeom prst="rect">
             <a:avLst/>
           </a:prstGeom>
+          <a:solidFill>
+            <a:srgbClr val="009A9A"/>
+          </a:solidFill>
           <a:ln>
             <a:noFill/>
           </a:ln>
@@ -7362,17 +7250,6 @@
           <p:nvPr/>
         </p:nvSpPr>
         <p:spPr>
-          <a:gradFill>
-            <a:gsLst>
-              <a:gs pos="0">
-                <a:srgbClr val="0A182C"/>
-              </a:gs>
-              <a:gs pos="100000">
-                <a:srgbClr val="005E6E"/>
-              </a:gs>
-            </a:gsLst>
-            <a:lin ang="16200000" scaled="0"/>
-          </a:gradFill>
           <a:xfrm>
             <a:off x="0" y="0"/>
             <a:ext cx="4631801" cy="6858000"/>
@@ -7380,6 +7257,9 @@
           <a:prstGeom prst="rect">
             <a:avLst/>
           </a:prstGeom>
+          <a:solidFill>
+            <a:srgbClr val="0A182C"/>
+          </a:solidFill>
           <a:ln>
             <a:noFill/>
           </a:ln>
@@ -7742,17 +7622,6 @@
           <p:nvPr/>
         </p:nvSpPr>
         <p:spPr>
-          <a:gradFill>
-            <a:gsLst>
-              <a:gs pos="0">
-                <a:srgbClr val="005E6E"/>
-              </a:gs>
-              <a:gs pos="100000">
-                <a:srgbClr val="009A9A"/>
-              </a:gs>
-            </a:gsLst>
-            <a:lin ang="5400000" scaled="0"/>
-          </a:gradFill>
           <a:xfrm>
             <a:off x="4875580" y="182880"/>
             <a:ext cx="6837883" cy="2042160"/>
@@ -7760,6 +7629,9 @@
           <a:prstGeom prst="rect">
             <a:avLst/>
           </a:prstGeom>
+          <a:solidFill>
+            <a:srgbClr val="005E6E"/>
+          </a:solidFill>
           <a:ln>
             <a:noFill/>
           </a:ln>
@@ -7872,17 +7744,6 @@
           <p:nvPr/>
         </p:nvSpPr>
         <p:spPr>
-          <a:gradFill>
-            <a:gsLst>
-              <a:gs pos="0">
-                <a:srgbClr val="005E6E"/>
-              </a:gs>
-              <a:gs pos="100000">
-                <a:srgbClr val="009A9A"/>
-              </a:gs>
-            </a:gsLst>
-            <a:lin ang="5400000" scaled="0"/>
-          </a:gradFill>
           <a:xfrm>
             <a:off x="4875580" y="2371344"/>
             <a:ext cx="6837883" cy="2042160"/>
@@ -7890,6 +7751,9 @@
           <a:prstGeom prst="rect">
             <a:avLst/>
           </a:prstGeom>
+          <a:solidFill>
+            <a:srgbClr val="005E6E"/>
+          </a:solidFill>
           <a:ln>
             <a:noFill/>
           </a:ln>
@@ -8002,17 +7866,6 @@
           <p:nvPr/>
         </p:nvSpPr>
         <p:spPr>
-          <a:gradFill>
-            <a:gsLst>
-              <a:gs pos="0">
-                <a:srgbClr val="005E6E"/>
-              </a:gs>
-              <a:gs pos="100000">
-                <a:srgbClr val="009A9A"/>
-              </a:gs>
-            </a:gsLst>
-            <a:lin ang="5400000" scaled="0"/>
-          </a:gradFill>
           <a:xfrm>
             <a:off x="4875580" y="4559808"/>
             <a:ext cx="6837883" cy="2042160"/>
@@ -8020,6 +7873,9 @@
           <a:prstGeom prst="rect">
             <a:avLst/>
           </a:prstGeom>
+          <a:solidFill>
+            <a:srgbClr val="005E6E"/>
+          </a:solidFill>
           <a:ln>
             <a:noFill/>
           </a:ln>
@@ -8457,17 +8313,6 @@
           <p:nvPr/>
         </p:nvSpPr>
         <p:spPr>
-          <a:gradFill>
-            <a:gsLst>
-              <a:gs pos="0">
-                <a:srgbClr val="005E6E"/>
-              </a:gs>
-              <a:gs pos="100000">
-                <a:srgbClr val="009A9A"/>
-              </a:gs>
-            </a:gsLst>
-            <a:lin ang="5400000" scaled="0"/>
-          </a:gradFill>
           <a:xfrm>
             <a:off x="539496" y="1458468"/>
             <a:ext cx="11173968" cy="640080"/>
@@ -8475,6 +8320,9 @@
           <a:prstGeom prst="rect">
             <a:avLst/>
           </a:prstGeom>
+          <a:solidFill>
+            <a:srgbClr val="005E6E"/>
+          </a:solidFill>
           <a:ln>
             <a:noFill/>
           </a:ln>
@@ -8542,17 +8390,6 @@
           <p:nvPr/>
         </p:nvSpPr>
         <p:spPr>
-          <a:gradFill>
-            <a:gsLst>
-              <a:gs pos="0">
-                <a:srgbClr val="0A182C"/>
-              </a:gs>
-              <a:gs pos="100000">
-                <a:srgbClr val="005E6E"/>
-              </a:gs>
-            </a:gsLst>
-            <a:lin ang="16200000" scaled="0"/>
-          </a:gradFill>
           <a:xfrm>
             <a:off x="676656" y="2253996"/>
             <a:ext cx="3496056" cy="4128516"/>
@@ -8560,6 +8397,9 @@
           <a:prstGeom prst="rect">
             <a:avLst/>
           </a:prstGeom>
+          <a:solidFill>
+            <a:srgbClr val="0A182C"/>
+          </a:solidFill>
           <a:ln>
             <a:noFill/>
           </a:ln>
@@ -8683,17 +8523,6 @@
           <p:nvPr/>
         </p:nvSpPr>
         <p:spPr>
-          <a:gradFill>
-            <a:gsLst>
-              <a:gs pos="0">
-                <a:srgbClr val="005E6E"/>
-              </a:gs>
-              <a:gs pos="100000">
-                <a:srgbClr val="009A9A"/>
-              </a:gs>
-            </a:gsLst>
-            <a:lin ang="16200000" scaled="0"/>
-          </a:gradFill>
           <a:xfrm>
             <a:off x="4309872" y="2253996"/>
             <a:ext cx="3496056" cy="4128516"/>
@@ -8701,6 +8530,9 @@
           <a:prstGeom prst="rect">
             <a:avLst/>
           </a:prstGeom>
+          <a:solidFill>
+            <a:srgbClr val="005E6E"/>
+          </a:solidFill>
           <a:ln>
             <a:noFill/>
           </a:ln>
@@ -8824,17 +8656,6 @@
           <p:nvPr/>
         </p:nvSpPr>
         <p:spPr>
-          <a:gradFill>
-            <a:gsLst>
-              <a:gs pos="0">
-                <a:srgbClr val="009A9A"/>
-              </a:gs>
-              <a:gs pos="100000">
-                <a:srgbClr val="00C4CC"/>
-              </a:gs>
-            </a:gsLst>
-            <a:lin ang="16200000" scaled="0"/>
-          </a:gradFill>
           <a:xfrm>
             <a:off x="7943088" y="2253996"/>
             <a:ext cx="3496056" cy="4128516"/>
@@ -8842,6 +8663,9 @@
           <a:prstGeom prst="rect">
             <a:avLst/>
           </a:prstGeom>
+          <a:solidFill>
+            <a:srgbClr val="009A9A"/>
+          </a:solidFill>
           <a:ln>
             <a:noFill/>
           </a:ln>
@@ -9324,17 +9148,6 @@
           <p:nvPr/>
         </p:nvSpPr>
         <p:spPr>
-          <a:gradFill>
-            <a:gsLst>
-              <a:gs pos="0">
-                <a:srgbClr val="005E6E"/>
-              </a:gs>
-              <a:gs pos="100000">
-                <a:srgbClr val="009A9A"/>
-              </a:gs>
-            </a:gsLst>
-            <a:lin ang="16200000" scaled="0"/>
-          </a:gradFill>
           <a:xfrm>
             <a:off x="676656" y="1522476"/>
             <a:ext cx="3496056" cy="4494276"/>
@@ -9342,6 +9155,9 @@
           <a:prstGeom prst="rect">
             <a:avLst/>
           </a:prstGeom>
+          <a:solidFill>
+            <a:srgbClr val="005E6E"/>
+          </a:solidFill>
           <a:ln>
             <a:noFill/>
           </a:ln>
@@ -9465,17 +9281,6 @@
           <p:nvPr/>
         </p:nvSpPr>
         <p:spPr>
-          <a:gradFill>
-            <a:gsLst>
-              <a:gs pos="0">
-                <a:srgbClr val="009A9A"/>
-              </a:gs>
-              <a:gs pos="100000">
-                <a:srgbClr val="00C4CC"/>
-              </a:gs>
-            </a:gsLst>
-            <a:lin ang="16200000" scaled="0"/>
-          </a:gradFill>
           <a:xfrm>
             <a:off x="4309872" y="1522476"/>
             <a:ext cx="3496056" cy="4494276"/>
@@ -9483,6 +9288,9 @@
           <a:prstGeom prst="rect">
             <a:avLst/>
           </a:prstGeom>
+          <a:solidFill>
+            <a:srgbClr val="009A9A"/>
+          </a:solidFill>
           <a:ln>
             <a:noFill/>
           </a:ln>
@@ -9606,17 +9414,6 @@
           <p:nvPr/>
         </p:nvSpPr>
         <p:spPr>
-          <a:gradFill>
-            <a:gsLst>
-              <a:gs pos="0">
-                <a:srgbClr val="00C4CC"/>
-              </a:gs>
-              <a:gs pos="100000">
-                <a:srgbClr val="3DD9E0"/>
-              </a:gs>
-            </a:gsLst>
-            <a:lin ang="16200000" scaled="0"/>
-          </a:gradFill>
           <a:xfrm>
             <a:off x="7943088" y="1522476"/>
             <a:ext cx="3496056" cy="4494276"/>
@@ -9624,6 +9421,9 @@
           <a:prstGeom prst="rect">
             <a:avLst/>
           </a:prstGeom>
+          <a:solidFill>
+            <a:srgbClr val="00C4CC"/>
+          </a:solidFill>
           <a:ln>
             <a:noFill/>
           </a:ln>
@@ -10140,17 +9940,6 @@
           <p:nvPr/>
         </p:nvSpPr>
         <p:spPr>
-          <a:gradFill>
-            <a:gsLst>
-              <a:gs pos="0">
-                <a:srgbClr val="005E6E"/>
-              </a:gs>
-              <a:gs pos="100000">
-                <a:srgbClr val="009A9A"/>
-              </a:gs>
-            </a:gsLst>
-            <a:lin ang="16200000" scaled="0"/>
-          </a:gradFill>
           <a:xfrm>
             <a:off x="630936" y="2043684"/>
             <a:ext cx="4022354" cy="4384548"/>
@@ -10158,6 +9947,9 @@
           <a:prstGeom prst="rect">
             <a:avLst/>
           </a:prstGeom>
+          <a:solidFill>
+            <a:srgbClr val="005E6E"/>
+          </a:solidFill>
           <a:ln>
             <a:noFill/>
           </a:ln>
@@ -12404,17 +12196,6 @@
           <p:nvPr/>
         </p:nvSpPr>
         <p:spPr>
-          <a:gradFill>
-            <a:gsLst>
-              <a:gs pos="0">
-                <a:srgbClr val="005E6E"/>
-              </a:gs>
-              <a:gs pos="100000">
-                <a:srgbClr val="009A9A"/>
-              </a:gs>
-            </a:gsLst>
-            <a:lin ang="5400000" scaled="0"/>
-          </a:gradFill>
           <a:xfrm>
             <a:off x="630936" y="2034540"/>
             <a:ext cx="640080" cy="834847"/>
@@ -12422,6 +12203,9 @@
           <a:prstGeom prst="rect">
             <a:avLst/>
           </a:prstGeom>
+          <a:solidFill>
+            <a:srgbClr val="005E6E"/>
+          </a:solidFill>
           <a:ln>
             <a:noFill/>
           </a:ln>
@@ -12608,17 +12392,6 @@
           <p:nvPr/>
         </p:nvSpPr>
         <p:spPr>
-          <a:gradFill>
-            <a:gsLst>
-              <a:gs pos="0">
-                <a:srgbClr val="005E6E"/>
-              </a:gs>
-              <a:gs pos="100000">
-                <a:srgbClr val="009A9A"/>
-              </a:gs>
-            </a:gsLst>
-            <a:lin ang="5400000" scaled="0"/>
-          </a:gradFill>
           <a:xfrm>
             <a:off x="630936" y="2979115"/>
             <a:ext cx="640080" cy="834847"/>
@@ -12626,6 +12399,9 @@
           <a:prstGeom prst="rect">
             <a:avLst/>
           </a:prstGeom>
+          <a:solidFill>
+            <a:srgbClr val="005E6E"/>
+          </a:solidFill>
           <a:ln>
             <a:noFill/>
           </a:ln>
@@ -12812,17 +12588,6 @@
           <p:nvPr/>
         </p:nvSpPr>
         <p:spPr>
-          <a:gradFill>
-            <a:gsLst>
-              <a:gs pos="0">
-                <a:srgbClr val="005E6E"/>
-              </a:gs>
-              <a:gs pos="100000">
-                <a:srgbClr val="009A9A"/>
-              </a:gs>
-            </a:gsLst>
-            <a:lin ang="5400000" scaled="0"/>
-          </a:gradFill>
           <a:xfrm>
             <a:off x="630936" y="3923690"/>
             <a:ext cx="640080" cy="834847"/>
@@ -12830,6 +12595,9 @@
           <a:prstGeom prst="rect">
             <a:avLst/>
           </a:prstGeom>
+          <a:solidFill>
+            <a:srgbClr val="005E6E"/>
+          </a:solidFill>
           <a:ln>
             <a:noFill/>
           </a:ln>
@@ -13016,17 +12784,6 @@
           <p:nvPr/>
         </p:nvSpPr>
         <p:spPr>
-          <a:gradFill>
-            <a:gsLst>
-              <a:gs pos="0">
-                <a:srgbClr val="005E6E"/>
-              </a:gs>
-              <a:gs pos="100000">
-                <a:srgbClr val="009A9A"/>
-              </a:gs>
-            </a:gsLst>
-            <a:lin ang="5400000" scaled="0"/>
-          </a:gradFill>
           <a:xfrm>
             <a:off x="630936" y="4868265"/>
             <a:ext cx="640080" cy="834847"/>
@@ -13034,6 +12791,9 @@
           <a:prstGeom prst="rect">
             <a:avLst/>
           </a:prstGeom>
+          <a:solidFill>
+            <a:srgbClr val="005E6E"/>
+          </a:solidFill>
           <a:ln>
             <a:noFill/>
           </a:ln>
@@ -13220,17 +12980,6 @@
           <p:nvPr/>
         </p:nvSpPr>
         <p:spPr>
-          <a:gradFill>
-            <a:gsLst>
-              <a:gs pos="0">
-                <a:srgbClr val="005E6E"/>
-              </a:gs>
-              <a:gs pos="100000">
-                <a:srgbClr val="009A9A"/>
-              </a:gs>
-            </a:gsLst>
-            <a:lin ang="5400000" scaled="0"/>
-          </a:gradFill>
           <a:xfrm>
             <a:off x="630936" y="5812840"/>
             <a:ext cx="640080" cy="834847"/>
@@ -13238,6 +12987,9 @@
           <a:prstGeom prst="rect">
             <a:avLst/>
           </a:prstGeom>
+          <a:solidFill>
+            <a:srgbClr val="005E6E"/>
+          </a:solidFill>
           <a:ln>
             <a:noFill/>
           </a:ln>
@@ -15223,17 +14975,6 @@
           <p:nvPr/>
         </p:nvSpPr>
         <p:spPr>
-          <a:gradFill>
-            <a:gsLst>
-              <a:gs pos="0">
-                <a:srgbClr val="005E6E"/>
-              </a:gs>
-              <a:gs pos="100000">
-                <a:srgbClr val="009A9A"/>
-              </a:gs>
-            </a:gsLst>
-            <a:lin ang="16200000" scaled="0"/>
-          </a:gradFill>
           <a:xfrm>
             <a:off x="630936" y="2071116"/>
             <a:ext cx="4875580" cy="4402836"/>
@@ -15241,6 +14982,9 @@
           <a:prstGeom prst="rect">
             <a:avLst/>
           </a:prstGeom>
+          <a:solidFill>
+            <a:srgbClr val="005E6E"/>
+          </a:solidFill>
           <a:ln>
             <a:noFill/>
           </a:ln>
@@ -17022,17 +16766,6 @@
           <p:nvPr/>
         </p:nvSpPr>
         <p:spPr>
-          <a:gradFill>
-            <a:gsLst>
-              <a:gs pos="0">
-                <a:srgbClr val="005E6E"/>
-              </a:gs>
-              <a:gs pos="100000">
-                <a:srgbClr val="009A9A"/>
-              </a:gs>
-            </a:gsLst>
-            <a:lin ang="16200000" scaled="0"/>
-          </a:gradFill>
           <a:xfrm>
             <a:off x="6286500" y="1458468"/>
             <a:ext cx="5765292" cy="4997196"/>
@@ -17040,6 +16773,9 @@
           <a:prstGeom prst="rect">
             <a:avLst/>
           </a:prstGeom>
+          <a:solidFill>
+            <a:srgbClr val="005E6E"/>
+          </a:solidFill>
           <a:ln>
             <a:noFill/>
           </a:ln>
@@ -17602,17 +17338,6 @@
           <p:nvPr/>
         </p:nvSpPr>
         <p:spPr>
-          <a:gradFill>
-            <a:gsLst>
-              <a:gs pos="0">
-                <a:srgbClr val="005E6E"/>
-              </a:gs>
-              <a:gs pos="100000">
-                <a:srgbClr val="009A9A"/>
-              </a:gs>
-            </a:gsLst>
-            <a:lin ang="16200000" scaled="0"/>
-          </a:gradFill>
           <a:xfrm>
             <a:off x="676656" y="1495044"/>
             <a:ext cx="3496056" cy="4796028"/>
@@ -17620,6 +17345,9 @@
           <a:prstGeom prst="rect">
             <a:avLst/>
           </a:prstGeom>
+          <a:solidFill>
+            <a:srgbClr val="005E6E"/>
+          </a:solidFill>
           <a:ln>
             <a:noFill/>
           </a:ln>
@@ -17777,17 +17505,6 @@
           <p:nvPr/>
         </p:nvSpPr>
         <p:spPr>
-          <a:gradFill>
-            <a:gsLst>
-              <a:gs pos="0">
-                <a:srgbClr val="005E6E"/>
-              </a:gs>
-              <a:gs pos="100000">
-                <a:srgbClr val="009A9A"/>
-              </a:gs>
-            </a:gsLst>
-            <a:lin ang="16200000" scaled="0"/>
-          </a:gradFill>
           <a:xfrm>
             <a:off x="4309872" y="1495044"/>
             <a:ext cx="3496056" cy="4796028"/>
@@ -17795,6 +17512,9 @@
           <a:prstGeom prst="rect">
             <a:avLst/>
           </a:prstGeom>
+          <a:solidFill>
+            <a:srgbClr val="005E6E"/>
+          </a:solidFill>
           <a:ln>
             <a:noFill/>
           </a:ln>
@@ -17952,17 +17672,6 @@
           <p:nvPr/>
         </p:nvSpPr>
         <p:spPr>
-          <a:gradFill>
-            <a:gsLst>
-              <a:gs pos="0">
-                <a:srgbClr val="005E6E"/>
-              </a:gs>
-              <a:gs pos="100000">
-                <a:srgbClr val="009A9A"/>
-              </a:gs>
-            </a:gsLst>
-            <a:lin ang="16200000" scaled="0"/>
-          </a:gradFill>
           <a:xfrm>
             <a:off x="7943088" y="1495044"/>
             <a:ext cx="3496056" cy="4796028"/>
@@ -17970,6 +17679,9 @@
           <a:prstGeom prst="rect">
             <a:avLst/>
           </a:prstGeom>
+          <a:solidFill>
+            <a:srgbClr val="005E6E"/>
+          </a:solidFill>
           <a:ln>
             <a:noFill/>
           </a:ln>
@@ -18452,17 +18164,6 @@
           <p:nvPr/>
         </p:nvSpPr>
         <p:spPr>
-          <a:gradFill>
-            <a:gsLst>
-              <a:gs pos="0">
-                <a:srgbClr val="005E6E"/>
-              </a:gs>
-              <a:gs pos="100000">
-                <a:srgbClr val="009A9A"/>
-              </a:gs>
-            </a:gsLst>
-            <a:lin ang="16200000" scaled="0"/>
-          </a:gradFill>
           <a:xfrm>
             <a:off x="676656" y="1458468"/>
             <a:ext cx="3496056" cy="2361438"/>
@@ -18470,6 +18171,9 @@
           <a:prstGeom prst="rect">
             <a:avLst/>
           </a:prstGeom>
+          <a:solidFill>
+            <a:srgbClr val="005E6E"/>
+          </a:solidFill>
           <a:ln>
             <a:noFill/>
           </a:ln>
@@ -18593,17 +18297,6 @@
           <p:nvPr/>
         </p:nvSpPr>
         <p:spPr>
-          <a:gradFill>
-            <a:gsLst>
-              <a:gs pos="0">
-                <a:srgbClr val="005E6E"/>
-              </a:gs>
-              <a:gs pos="100000">
-                <a:srgbClr val="009A9A"/>
-              </a:gs>
-            </a:gsLst>
-            <a:lin ang="16200000" scaled="0"/>
-          </a:gradFill>
           <a:xfrm>
             <a:off x="4309872" y="1458468"/>
             <a:ext cx="3496056" cy="2361438"/>
@@ -18611,6 +18304,9 @@
           <a:prstGeom prst="rect">
             <a:avLst/>
           </a:prstGeom>
+          <a:solidFill>
+            <a:srgbClr val="005E6E"/>
+          </a:solidFill>
           <a:ln>
             <a:noFill/>
           </a:ln>
@@ -18734,17 +18430,6 @@
           <p:nvPr/>
         </p:nvSpPr>
         <p:spPr>
-          <a:gradFill>
-            <a:gsLst>
-              <a:gs pos="0">
-                <a:srgbClr val="005E6E"/>
-              </a:gs>
-              <a:gs pos="100000">
-                <a:srgbClr val="009A9A"/>
-              </a:gs>
-            </a:gsLst>
-            <a:lin ang="16200000" scaled="0"/>
-          </a:gradFill>
           <a:xfrm>
             <a:off x="7943088" y="1458468"/>
             <a:ext cx="3496056" cy="2361438"/>
@@ -18752,6 +18437,9 @@
           <a:prstGeom prst="rect">
             <a:avLst/>
           </a:prstGeom>
+          <a:solidFill>
+            <a:srgbClr val="005E6E"/>
+          </a:solidFill>
           <a:ln>
             <a:noFill/>
           </a:ln>
@@ -18875,17 +18563,6 @@
           <p:nvPr/>
         </p:nvSpPr>
         <p:spPr>
-          <a:gradFill>
-            <a:gsLst>
-              <a:gs pos="0">
-                <a:srgbClr val="009A9A"/>
-              </a:gs>
-              <a:gs pos="100000">
-                <a:srgbClr val="00C4CC"/>
-              </a:gs>
-            </a:gsLst>
-            <a:lin ang="16200000" scaled="0"/>
-          </a:gradFill>
           <a:xfrm>
             <a:off x="676656" y="3957066"/>
             <a:ext cx="3496056" cy="2361438"/>
@@ -18893,6 +18570,9 @@
           <a:prstGeom prst="rect">
             <a:avLst/>
           </a:prstGeom>
+          <a:solidFill>
+            <a:srgbClr val="009A9A"/>
+          </a:solidFill>
           <a:ln>
             <a:noFill/>
           </a:ln>
@@ -19016,17 +18696,6 @@
           <p:nvPr/>
         </p:nvSpPr>
         <p:spPr>
-          <a:gradFill>
-            <a:gsLst>
-              <a:gs pos="0">
-                <a:srgbClr val="009A9A"/>
-              </a:gs>
-              <a:gs pos="100000">
-                <a:srgbClr val="00C4CC"/>
-              </a:gs>
-            </a:gsLst>
-            <a:lin ang="16200000" scaled="0"/>
-          </a:gradFill>
           <a:xfrm>
             <a:off x="4309872" y="3957066"/>
             <a:ext cx="3496056" cy="2361438"/>
@@ -19034,6 +18703,9 @@
           <a:prstGeom prst="rect">
             <a:avLst/>
           </a:prstGeom>
+          <a:solidFill>
+            <a:srgbClr val="009A9A"/>
+          </a:solidFill>
           <a:ln>
             <a:noFill/>
           </a:ln>
@@ -19157,17 +18829,6 @@
           <p:nvPr/>
         </p:nvSpPr>
         <p:spPr>
-          <a:gradFill>
-            <a:gsLst>
-              <a:gs pos="0">
-                <a:srgbClr val="009A9A"/>
-              </a:gs>
-              <a:gs pos="100000">
-                <a:srgbClr val="00C4CC"/>
-              </a:gs>
-            </a:gsLst>
-            <a:lin ang="16200000" scaled="0"/>
-          </a:gradFill>
           <a:xfrm>
             <a:off x="7943088" y="3957066"/>
             <a:ext cx="3496056" cy="2361438"/>
@@ -19175,6 +18836,9 @@
           <a:prstGeom prst="rect">
             <a:avLst/>
           </a:prstGeom>
+          <a:solidFill>
+            <a:srgbClr val="009A9A"/>
+          </a:solidFill>
           <a:ln>
             <a:noFill/>
           </a:ln>
@@ -19623,17 +19287,6 @@
           <p:nvPr/>
         </p:nvSpPr>
         <p:spPr>
-          <a:gradFill>
-            <a:gsLst>
-              <a:gs pos="0">
-                <a:srgbClr val="005E6E"/>
-              </a:gs>
-              <a:gs pos="100000">
-                <a:srgbClr val="009A9A"/>
-              </a:gs>
-            </a:gsLst>
-            <a:lin ang="5400000" scaled="0"/>
-          </a:gradFill>
           <a:xfrm>
             <a:off x="676656" y="1458468"/>
             <a:ext cx="5312664" cy="2379726"/>
@@ -19641,6 +19294,9 @@
           <a:prstGeom prst="rect">
             <a:avLst/>
           </a:prstGeom>
+          <a:solidFill>
+            <a:srgbClr val="005E6E"/>
+          </a:solidFill>
           <a:ln>
             <a:noFill/>
           </a:ln>
@@ -19810,17 +19466,6 @@
           <p:nvPr/>
         </p:nvSpPr>
         <p:spPr>
-          <a:gradFill>
-            <a:gsLst>
-              <a:gs pos="0">
-                <a:srgbClr val="005E6E"/>
-              </a:gs>
-              <a:gs pos="100000">
-                <a:srgbClr val="009A9A"/>
-              </a:gs>
-            </a:gsLst>
-            <a:lin ang="5400000" scaled="0"/>
-          </a:gradFill>
           <a:xfrm>
             <a:off x="6126480" y="1458468"/>
             <a:ext cx="5312664" cy="2379726"/>
@@ -19828,6 +19473,9 @@
           <a:prstGeom prst="rect">
             <a:avLst/>
           </a:prstGeom>
+          <a:solidFill>
+            <a:srgbClr val="005E6E"/>
+          </a:solidFill>
           <a:ln>
             <a:noFill/>
           </a:ln>
@@ -19997,17 +19645,6 @@
           <p:nvPr/>
         </p:nvSpPr>
         <p:spPr>
-          <a:gradFill>
-            <a:gsLst>
-              <a:gs pos="0">
-                <a:srgbClr val="005E6E"/>
-              </a:gs>
-              <a:gs pos="100000">
-                <a:srgbClr val="009A9A"/>
-              </a:gs>
-            </a:gsLst>
-            <a:lin ang="5400000" scaled="0"/>
-          </a:gradFill>
           <a:xfrm>
             <a:off x="676656" y="4002786"/>
             <a:ext cx="5312664" cy="2379726"/>
@@ -20015,6 +19652,9 @@
           <a:prstGeom prst="rect">
             <a:avLst/>
           </a:prstGeom>
+          <a:solidFill>
+            <a:srgbClr val="005E6E"/>
+          </a:solidFill>
           <a:ln>
             <a:noFill/>
           </a:ln>
@@ -20184,17 +19824,6 @@
           <p:nvPr/>
         </p:nvSpPr>
         <p:spPr>
-          <a:gradFill>
-            <a:gsLst>
-              <a:gs pos="0">
-                <a:srgbClr val="005E6E"/>
-              </a:gs>
-              <a:gs pos="100000">
-                <a:srgbClr val="009A9A"/>
-              </a:gs>
-            </a:gsLst>
-            <a:lin ang="5400000" scaled="0"/>
-          </a:gradFill>
           <a:xfrm>
             <a:off x="6126480" y="4002786"/>
             <a:ext cx="5312664" cy="2379726"/>
@@ -20202,6 +19831,9 @@
           <a:prstGeom prst="rect">
             <a:avLst/>
           </a:prstGeom>
+          <a:solidFill>
+            <a:srgbClr val="005E6E"/>
+          </a:solidFill>
           <a:ln>
             <a:noFill/>
           </a:ln>
@@ -22559,17 +22191,6 @@
           <p:nvPr/>
         </p:nvSpPr>
         <p:spPr>
-          <a:gradFill>
-            <a:gsLst>
-              <a:gs pos="0">
-                <a:srgbClr val="0A182C"/>
-              </a:gs>
-              <a:gs pos="100000">
-                <a:srgbClr val="005E6E"/>
-              </a:gs>
-            </a:gsLst>
-            <a:lin ang="5400000" scaled="0"/>
-          </a:gradFill>
           <a:xfrm>
             <a:off x="950976" y="4766310"/>
             <a:ext cx="10287000" cy="1508760"/>
@@ -22577,6 +22198,9 @@
           <a:prstGeom prst="rect">
             <a:avLst/>
           </a:prstGeom>
+          <a:solidFill>
+            <a:srgbClr val="0A182C"/>
+          </a:solidFill>
           <a:ln>
             <a:noFill/>
           </a:ln>
@@ -23091,17 +22715,6 @@
           <p:nvPr/>
         </p:nvSpPr>
         <p:spPr>
-          <a:gradFill>
-            <a:gsLst>
-              <a:gs pos="0">
-                <a:srgbClr val="005E6E"/>
-              </a:gs>
-              <a:gs pos="100000">
-                <a:srgbClr val="009A9A"/>
-              </a:gs>
-            </a:gsLst>
-            <a:lin ang="5400000" scaled="0"/>
-          </a:gradFill>
           <a:xfrm>
             <a:off x="594360" y="5623560"/>
             <a:ext cx="6338255" cy="658368"/>
@@ -23109,6 +22722,9 @@
           <a:prstGeom prst="rect">
             <a:avLst/>
           </a:prstGeom>
+          <a:solidFill>
+            <a:srgbClr val="005E6E"/>
+          </a:solidFill>
           <a:ln>
             <a:noFill/>
           </a:ln>
@@ -23501,17 +23117,6 @@
           <p:nvPr/>
         </p:nvSpPr>
         <p:spPr>
-          <a:gradFill>
-            <a:gsLst>
-              <a:gs pos="0">
-                <a:srgbClr val="005E6E"/>
-              </a:gs>
-              <a:gs pos="100000">
-                <a:srgbClr val="009A9A"/>
-              </a:gs>
-            </a:gsLst>
-            <a:lin ang="16200000" scaled="0"/>
-          </a:gradFill>
           <a:xfrm>
             <a:off x="676656" y="1549908"/>
             <a:ext cx="2587752" cy="4631436"/>
@@ -23519,6 +23124,9 @@
           <a:prstGeom prst="rect">
             <a:avLst/>
           </a:prstGeom>
+          <a:solidFill>
+            <a:srgbClr val="005E6E"/>
+          </a:solidFill>
           <a:ln>
             <a:noFill/>
           </a:ln>
@@ -23665,17 +23273,6 @@
           <p:nvPr/>
         </p:nvSpPr>
         <p:spPr>
-          <a:gradFill>
-            <a:gsLst>
-              <a:gs pos="0">
-                <a:srgbClr val="009A9A"/>
-              </a:gs>
-              <a:gs pos="100000">
-                <a:srgbClr val="00C4CC"/>
-              </a:gs>
-            </a:gsLst>
-            <a:lin ang="16200000" scaled="0"/>
-          </a:gradFill>
           <a:xfrm>
             <a:off x="3401568" y="1549908"/>
             <a:ext cx="2587752" cy="4631436"/>
@@ -23683,6 +23280,9 @@
           <a:prstGeom prst="rect">
             <a:avLst/>
           </a:prstGeom>
+          <a:solidFill>
+            <a:srgbClr val="009A9A"/>
+          </a:solidFill>
           <a:ln>
             <a:noFill/>
           </a:ln>
@@ -23829,17 +23429,6 @@
           <p:nvPr/>
         </p:nvSpPr>
         <p:spPr>
-          <a:gradFill>
-            <a:gsLst>
-              <a:gs pos="0">
-                <a:srgbClr val="00C4CC"/>
-              </a:gs>
-              <a:gs pos="100000">
-                <a:srgbClr val="3DD9E0"/>
-              </a:gs>
-            </a:gsLst>
-            <a:lin ang="16200000" scaled="0"/>
-          </a:gradFill>
           <a:xfrm>
             <a:off x="6126480" y="1549908"/>
             <a:ext cx="2587752" cy="4631436"/>
@@ -23847,6 +23436,9 @@
           <a:prstGeom prst="rect">
             <a:avLst/>
           </a:prstGeom>
+          <a:solidFill>
+            <a:srgbClr val="00C4CC"/>
+          </a:solidFill>
           <a:ln>
             <a:noFill/>
           </a:ln>
@@ -23993,17 +23585,6 @@
           <p:nvPr/>
         </p:nvSpPr>
         <p:spPr>
-          <a:gradFill>
-            <a:gsLst>
-              <a:gs pos="0">
-                <a:srgbClr val="009A9A"/>
-              </a:gs>
-              <a:gs pos="100000">
-                <a:srgbClr val="3DD9E0"/>
-              </a:gs>
-            </a:gsLst>
-            <a:lin ang="16200000" scaled="0"/>
-          </a:gradFill>
           <a:xfrm>
             <a:off x="8851392" y="1549908"/>
             <a:ext cx="2587752" cy="4631436"/>
@@ -24011,6 +23592,9 @@
           <a:prstGeom prst="rect">
             <a:avLst/>
           </a:prstGeom>
+          <a:solidFill>
+            <a:srgbClr val="009A9A"/>
+          </a:solidFill>
           <a:ln>
             <a:noFill/>
           </a:ln>
@@ -24516,17 +24100,6 @@
           <p:nvPr/>
         </p:nvSpPr>
         <p:spPr>
-          <a:gradFill>
-            <a:gsLst>
-              <a:gs pos="0">
-                <a:srgbClr val="0A182C"/>
-              </a:gs>
-              <a:gs pos="100000">
-                <a:srgbClr val="005E6E"/>
-              </a:gs>
-            </a:gsLst>
-            <a:lin ang="16200000" scaled="0"/>
-          </a:gradFill>
           <a:xfrm>
             <a:off x="539496" y="1476756"/>
             <a:ext cx="4631801" cy="5116068"/>
@@ -24534,6 +24107,9 @@
           <a:prstGeom prst="rect">
             <a:avLst/>
           </a:prstGeom>
+          <a:solidFill>
+            <a:srgbClr val="0A182C"/>
+          </a:solidFill>
           <a:ln>
             <a:noFill/>
           </a:ln>
@@ -24782,17 +24358,6 @@
           <p:nvPr/>
         </p:nvSpPr>
         <p:spPr>
-          <a:gradFill>
-            <a:gsLst>
-              <a:gs pos="0">
-                <a:srgbClr val="005E6E"/>
-              </a:gs>
-              <a:gs pos="100000">
-                <a:srgbClr val="009A9A"/>
-              </a:gs>
-            </a:gsLst>
-            <a:lin ang="5400000" scaled="0"/>
-          </a:gradFill>
           <a:xfrm>
             <a:off x="5658855" y="1476756"/>
             <a:ext cx="5963168" cy="1325880"/>
@@ -24800,6 +24365,9 @@
           <a:prstGeom prst="rect">
             <a:avLst/>
           </a:prstGeom>
+          <a:solidFill>
+            <a:srgbClr val="005E6E"/>
+          </a:solidFill>
           <a:ln>
             <a:noFill/>
           </a:ln>
@@ -24935,17 +24503,6 @@
           <p:nvPr/>
         </p:nvSpPr>
         <p:spPr>
-          <a:gradFill>
-            <a:gsLst>
-              <a:gs pos="0">
-                <a:srgbClr val="005E6E"/>
-              </a:gs>
-              <a:gs pos="100000">
-                <a:srgbClr val="009A9A"/>
-              </a:gs>
-            </a:gsLst>
-            <a:lin ang="5400000" scaled="0"/>
-          </a:gradFill>
           <a:xfrm>
             <a:off x="5658855" y="2967228"/>
             <a:ext cx="5963168" cy="1325880"/>
@@ -24953,6 +24510,9 @@
           <a:prstGeom prst="rect">
             <a:avLst/>
           </a:prstGeom>
+          <a:solidFill>
+            <a:srgbClr val="005E6E"/>
+          </a:solidFill>
           <a:ln>
             <a:noFill/>
           </a:ln>
@@ -25088,17 +24648,6 @@
           <p:nvPr/>
         </p:nvSpPr>
         <p:spPr>
-          <a:gradFill>
-            <a:gsLst>
-              <a:gs pos="0">
-                <a:srgbClr val="005E6E"/>
-              </a:gs>
-              <a:gs pos="100000">
-                <a:srgbClr val="009A9A"/>
-              </a:gs>
-            </a:gsLst>
-            <a:lin ang="5400000" scaled="0"/>
-          </a:gradFill>
           <a:xfrm>
             <a:off x="5658855" y="4457700"/>
             <a:ext cx="5963168" cy="1325880"/>
@@ -25106,6 +24655,9 @@
           <a:prstGeom prst="rect">
             <a:avLst/>
           </a:prstGeom>
+          <a:solidFill>
+            <a:srgbClr val="005E6E"/>
+          </a:solidFill>
           <a:ln>
             <a:noFill/>
           </a:ln>
@@ -25566,17 +25118,6 @@
           <p:nvPr/>
         </p:nvSpPr>
         <p:spPr>
-          <a:gradFill>
-            <a:gsLst>
-              <a:gs pos="0">
-                <a:srgbClr val="005E6E"/>
-              </a:gs>
-              <a:gs pos="100000">
-                <a:srgbClr val="009A9A"/>
-              </a:gs>
-            </a:gsLst>
-            <a:lin ang="16200000" scaled="0"/>
-          </a:gradFill>
           <a:xfrm>
             <a:off x="722376" y="1495044"/>
             <a:ext cx="3438144" cy="4631436"/>
@@ -25584,6 +25125,9 @@
           <a:prstGeom prst="rect">
             <a:avLst/>
           </a:prstGeom>
+          <a:solidFill>
+            <a:srgbClr val="005E6E"/>
+          </a:solidFill>
           <a:ln>
             <a:noFill/>
           </a:ln>
@@ -25752,17 +25296,6 @@
           <p:nvPr/>
         </p:nvSpPr>
         <p:spPr>
-          <a:gradFill>
-            <a:gsLst>
-              <a:gs pos="0">
-                <a:srgbClr val="009A9A"/>
-              </a:gs>
-              <a:gs pos="100000">
-                <a:srgbClr val="00C4CC"/>
-              </a:gs>
-            </a:gsLst>
-            <a:lin ang="16200000" scaled="0"/>
-          </a:gradFill>
           <a:xfrm>
             <a:off x="4325112" y="1495044"/>
             <a:ext cx="3438144" cy="4631436"/>
@@ -25770,6 +25303,9 @@
           <a:prstGeom prst="rect">
             <a:avLst/>
           </a:prstGeom>
+          <a:solidFill>
+            <a:srgbClr val="009A9A"/>
+          </a:solidFill>
           <a:ln>
             <a:noFill/>
           </a:ln>
@@ -25938,17 +25474,6 @@
           <p:nvPr/>
         </p:nvSpPr>
         <p:spPr>
-          <a:gradFill>
-            <a:gsLst>
-              <a:gs pos="0">
-                <a:srgbClr val="00C4CC"/>
-              </a:gs>
-              <a:gs pos="100000">
-                <a:srgbClr val="3DD9E0"/>
-              </a:gs>
-            </a:gsLst>
-            <a:lin ang="16200000" scaled="0"/>
-          </a:gradFill>
           <a:xfrm>
             <a:off x="7927848" y="1495044"/>
             <a:ext cx="3438144" cy="4631436"/>
@@ -25956,6 +25481,9 @@
           <a:prstGeom prst="rect">
             <a:avLst/>
           </a:prstGeom>
+          <a:solidFill>
+            <a:srgbClr val="00C4CC"/>
+          </a:solidFill>
           <a:ln>
             <a:noFill/>
           </a:ln>
@@ -27653,17 +27181,6 @@
           <p:nvPr/>
         </p:nvSpPr>
         <p:spPr>
-          <a:gradFill>
-            <a:gsLst>
-              <a:gs pos="0">
-                <a:srgbClr val="005E6E"/>
-              </a:gs>
-              <a:gs pos="100000">
-                <a:srgbClr val="009A9A"/>
-              </a:gs>
-            </a:gsLst>
-            <a:lin ang="16200000" scaled="0"/>
-          </a:gradFill>
           <a:xfrm>
             <a:off x="6286500" y="1458468"/>
             <a:ext cx="5765292" cy="5042916"/>
@@ -27671,6 +27188,9 @@
           <a:prstGeom prst="rect">
             <a:avLst/>
           </a:prstGeom>
+          <a:solidFill>
+            <a:srgbClr val="005E6E"/>
+          </a:solidFill>
           <a:ln>
             <a:noFill/>
           </a:ln>
@@ -28423,17 +27943,6 @@
           <p:nvPr/>
         </p:nvSpPr>
         <p:spPr>
-          <a:gradFill>
-            <a:gsLst>
-              <a:gs pos="0">
-                <a:srgbClr val="009A9A"/>
-              </a:gs>
-              <a:gs pos="100000">
-                <a:srgbClr val="00C4CC"/>
-              </a:gs>
-            </a:gsLst>
-            <a:lin ang="16200000" scaled="0"/>
-          </a:gradFill>
           <a:xfrm>
             <a:off x="3424428" y="1829257"/>
             <a:ext cx="2683764" cy="4214926"/>
@@ -28441,6 +27950,9 @@
           <a:prstGeom prst="rect">
             <a:avLst/>
           </a:prstGeom>
+          <a:solidFill>
+            <a:srgbClr val="009A9A"/>
+          </a:solidFill>
           <a:ln>
             <a:noFill/>
           </a:ln>
@@ -28587,17 +28099,6 @@
           <p:nvPr/>
         </p:nvSpPr>
         <p:spPr>
-          <a:gradFill>
-            <a:gsLst>
-              <a:gs pos="0">
-                <a:srgbClr val="005E6E"/>
-              </a:gs>
-              <a:gs pos="100000">
-                <a:srgbClr val="009A9A"/>
-              </a:gs>
-            </a:gsLst>
-            <a:lin ang="16200000" scaled="0"/>
-          </a:gradFill>
           <a:xfrm>
             <a:off x="6217920" y="2108606"/>
             <a:ext cx="2683764" cy="3935577"/>
@@ -28605,6 +28106,9 @@
           <a:prstGeom prst="rect">
             <a:avLst/>
           </a:prstGeom>
+          <a:solidFill>
+            <a:srgbClr val="005E6E"/>
+          </a:solidFill>
           <a:ln>
             <a:noFill/>
           </a:ln>

</xml_diff>